<commit_message>
Refresh research PDF typography and colors
</commit_message>
<xml_diff>
--- a/presentation/InverPINN_Presentation.pptx
+++ b/presentation/InverPINN_Presentation.pptx
@@ -2,22 +2,22 @@
 <file path=ppt/presentation.xml><?xml version="1.0" encoding="utf-8"?>
 <p:presentation xmlns:p="http://schemas.openxmlformats.org/presentationml/2006/main">
   <p:sldMasterIdLst>
-    <p:sldMasterId xmlns:r="http://schemas.openxmlformats.org/officeDocument/2006/relationships" id="2147483648" r:id="Rf356f0b13dfb4e59"/>
+    <p:sldMasterId xmlns:r="http://schemas.openxmlformats.org/officeDocument/2006/relationships" id="2147483648" r:id="R551d51e2746a4ea7"/>
   </p:sldMasterIdLst>
   <p:notesMasterIdLst>
-    <p:notesMasterId xmlns:r="http://schemas.openxmlformats.org/officeDocument/2006/relationships" r:id="R295f9dc73d134ea5"/>
+    <p:notesMasterId xmlns:r="http://schemas.openxmlformats.org/officeDocument/2006/relationships" r:id="R594c3392a0df499d"/>
   </p:notesMasterIdLst>
   <p:sldIdLst>
-    <p:sldId xmlns:r="http://schemas.openxmlformats.org/officeDocument/2006/relationships" id="256" r:id="Rfe480b7686844c34"/>
-    <p:sldId xmlns:r="http://schemas.openxmlformats.org/officeDocument/2006/relationships" id="257" r:id="Rebe8214444cf46e4"/>
-    <p:sldId xmlns:r="http://schemas.openxmlformats.org/officeDocument/2006/relationships" id="258" r:id="Rbea937d3bac845c9"/>
-    <p:sldId xmlns:r="http://schemas.openxmlformats.org/officeDocument/2006/relationships" id="259" r:id="Rbafe409a50274ed8"/>
-    <p:sldId xmlns:r="http://schemas.openxmlformats.org/officeDocument/2006/relationships" id="260" r:id="R2b828314700c49e3"/>
-    <p:sldId xmlns:r="http://schemas.openxmlformats.org/officeDocument/2006/relationships" id="261" r:id="R4d655d0bc487444a"/>
-    <p:sldId xmlns:r="http://schemas.openxmlformats.org/officeDocument/2006/relationships" id="262" r:id="R721bf5d45ed34102"/>
-    <p:sldId xmlns:r="http://schemas.openxmlformats.org/officeDocument/2006/relationships" id="263" r:id="R619b00c14b58447f"/>
-    <p:sldId xmlns:r="http://schemas.openxmlformats.org/officeDocument/2006/relationships" id="264" r:id="Rd5015fb14933487b"/>
-    <p:sldId xmlns:r="http://schemas.openxmlformats.org/officeDocument/2006/relationships" id="265" r:id="Ree9d0ced5b384932"/>
+    <p:sldId xmlns:r="http://schemas.openxmlformats.org/officeDocument/2006/relationships" id="256" r:id="Ra4b0ff1a67314677"/>
+    <p:sldId xmlns:r="http://schemas.openxmlformats.org/officeDocument/2006/relationships" id="257" r:id="R2398e39d585245d2"/>
+    <p:sldId xmlns:r="http://schemas.openxmlformats.org/officeDocument/2006/relationships" id="258" r:id="R39054ed5eb0d4c64"/>
+    <p:sldId xmlns:r="http://schemas.openxmlformats.org/officeDocument/2006/relationships" id="259" r:id="Ra8338a9481be4636"/>
+    <p:sldId xmlns:r="http://schemas.openxmlformats.org/officeDocument/2006/relationships" id="260" r:id="R9b8333322af24686"/>
+    <p:sldId xmlns:r="http://schemas.openxmlformats.org/officeDocument/2006/relationships" id="261" r:id="R80599b441e184e70"/>
+    <p:sldId xmlns:r="http://schemas.openxmlformats.org/officeDocument/2006/relationships" id="262" r:id="R21899cad0274460f"/>
+    <p:sldId xmlns:r="http://schemas.openxmlformats.org/officeDocument/2006/relationships" id="263" r:id="R83982d9d0a0e40e1"/>
+    <p:sldId xmlns:r="http://schemas.openxmlformats.org/officeDocument/2006/relationships" id="264" r:id="R4aeb35a11c4d43ff"/>
+    <p:sldId xmlns:r="http://schemas.openxmlformats.org/officeDocument/2006/relationships" id="265" r:id="R3d1fea93b0b8470b"/>
   </p:sldIdLst>
   <p:sldSz cx="12192000" cy="6858000"/>
   <p:notesSz cx="6858000" cy="9144000"/>
@@ -1449,7 +1449,7 @@
   </p:cSld>
   <p:clrMap bg1="lt1" tx1="dk1" bg2="lt2" tx2="dk2" accent1="accent1" accent2="accent2" accent3="accent3" accent4="accent4" accent5="accent5" accent6="accent6" hlink="hlink" folHlink="folHlink"/>
   <p:sldLayoutIdLst>
-    <p:sldLayoutId xmlns:r="http://schemas.openxmlformats.org/officeDocument/2006/relationships" id="2147483649" r:id="R25091aad97264271"/>
+    <p:sldLayoutId xmlns:r="http://schemas.openxmlformats.org/officeDocument/2006/relationships" id="2147483649" r:id="Ra41396da255f447b"/>
   </p:sldLayoutIdLst>
   <p:txStyles>
     <p:titleStyle>
@@ -2000,7 +2000,7 @@
           <p:cNvPr id="5" name="">
             <a:extLst xmlns:a="http://schemas.openxmlformats.org/drawingml/2006/main">
               <a:ext uri="{FF2B5EF4-FFF2-40B4-BE49-F238E27FC236}">
-                <a16:creationId xmlns:a16="http://schemas.microsoft.com/office/drawing/2014/main" id="{C5E7052F-2C3D-40F9-8C0D-92B795CD98F9}"/>
+                <a16:creationId xmlns:a16="http://schemas.microsoft.com/office/drawing/2014/main" id="{A27B8893-98CE-403E-9D15-969EEFBB9277}"/>
               </a:ext>
             </a:extLst>
           </p:cNvPr>
@@ -2031,21 +2031,21 @@
             <a:pPr>
               <a:defRPr sz="5700" b="1">
                 <a:solidFill>
-                  <a:srgbClr val="192D3D"/>
-                </a:solidFill>
-                <a:latin typeface="DejaVu Sans"/>
-                <a:ea typeface="DejaVu Sans"/>
-                <a:cs typeface="DejaVu Sans"/>
+                  <a:srgbClr val="262321"/>
+                </a:solidFill>
+                <a:latin typeface="Liberation Serif"/>
+                <a:ea typeface="Liberation Serif"/>
+                <a:cs typeface="Liberation Serif"/>
               </a:defRPr>
             </a:pPr>
             <a:r>
               <a:rPr sz="5700" b="1">
                 <a:solidFill>
-                  <a:srgbClr val="192D3D"/>
-                </a:solidFill>
-                <a:latin typeface="DejaVu Sans"/>
-                <a:ea typeface="DejaVu Sans"/>
-                <a:cs typeface="DejaVu Sans"/>
+                  <a:srgbClr val="262321"/>
+                </a:solidFill>
+                <a:latin typeface="Liberation Serif"/>
+                <a:ea typeface="Liberation Serif"/>
+                <a:cs typeface="Liberation Serif"/>
               </a:rPr>
               <a:t>InverPINN</a:t>
             </a:r>
@@ -2057,7 +2057,7 @@
           <p:cNvPr id="2" name="">
             <a:extLst xmlns:a="http://schemas.openxmlformats.org/drawingml/2006/main">
               <a:ext uri="{FF2B5EF4-FFF2-40B4-BE49-F238E27FC236}">
-                <a16:creationId xmlns:a16="http://schemas.microsoft.com/office/drawing/2014/main" id="{22974E30-DE3E-49AC-BE2F-B1F018C547D4}"/>
+                <a16:creationId xmlns:a16="http://schemas.microsoft.com/office/drawing/2014/main" id="{D1123277-27D9-4C90-878B-5754B87457DE}"/>
               </a:ext>
             </a:extLst>
           </p:cNvPr>
@@ -2088,21 +2088,21 @@
             <a:pPr>
               <a:defRPr sz="3300" b="1">
                 <a:solidFill>
-                  <a:srgbClr val="16688A"/>
-                </a:solidFill>
-                <a:latin typeface="DejaVu Sans"/>
-                <a:ea typeface="DejaVu Sans"/>
-                <a:cs typeface="DejaVu Sans"/>
+                  <a:srgbClr val="713E48"/>
+                </a:solidFill>
+                <a:latin typeface="Liberation Serif"/>
+                <a:ea typeface="Liberation Serif"/>
+                <a:cs typeface="Liberation Serif"/>
               </a:defRPr>
             </a:pPr>
             <a:r>
               <a:rPr sz="3300" b="1">
                 <a:solidFill>
-                  <a:srgbClr val="16688A"/>
-                </a:solidFill>
-                <a:latin typeface="DejaVu Sans"/>
-                <a:ea typeface="DejaVu Sans"/>
-                <a:cs typeface="DejaVu Sans"/>
+                  <a:srgbClr val="713E48"/>
+                </a:solidFill>
+                <a:latin typeface="Liberation Serif"/>
+                <a:ea typeface="Liberation Serif"/>
+                <a:cs typeface="Liberation Serif"/>
               </a:rPr>
               <a:t>Source-strength bias in physics-informed pollution inversion</a:t>
             </a:r>
@@ -2114,7 +2114,7 @@
           <p:cNvPr id="3" name="">
             <a:extLst xmlns:a="http://schemas.openxmlformats.org/drawingml/2006/main">
               <a:ext uri="{FF2B5EF4-FFF2-40B4-BE49-F238E27FC236}">
-                <a16:creationId xmlns:a16="http://schemas.microsoft.com/office/drawing/2014/main" id="{AD829C3B-5AD5-4A9C-9E44-97FC7019D94D}"/>
+                <a16:creationId xmlns:a16="http://schemas.microsoft.com/office/drawing/2014/main" id="{88EC2D27-84CB-48B9-B995-BE83FE6142B4}"/>
               </a:ext>
             </a:extLst>
           </p:cNvPr>
@@ -2145,21 +2145,21 @@
             <a:pPr>
               <a:defRPr sz="2250" b="0">
                 <a:solidFill>
-                  <a:srgbClr val="192D3D"/>
-                </a:solidFill>
-                <a:latin typeface="DejaVu Sans"/>
-                <a:ea typeface="DejaVu Sans"/>
-                <a:cs typeface="DejaVu Sans"/>
+                  <a:srgbClr val="262321"/>
+                </a:solidFill>
+                <a:latin typeface="Liberation Sans"/>
+                <a:ea typeface="Liberation Sans"/>
+                <a:cs typeface="Liberation Sans"/>
               </a:defRPr>
             </a:pPr>
             <a:r>
               <a:rPr sz="2250" b="0">
                 <a:solidFill>
-                  <a:srgbClr val="192D3D"/>
-                </a:solidFill>
-                <a:latin typeface="DejaVu Sans"/>
-                <a:ea typeface="DejaVu Sans"/>
-                <a:cs typeface="DejaVu Sans"/>
+                  <a:srgbClr val="262321"/>
+                </a:solidFill>
+                <a:latin typeface="Liberation Sans"/>
+                <a:ea typeface="Liberation Sans"/>
+                <a:cs typeface="Liberation Sans"/>
               </a:rPr>
               <a:t>How reliably can physics-informed neural networks recover a pollution source from sparse concentration measurements?</a:t>
             </a:r>
@@ -2171,7 +2171,7 @@
           <p:cNvPr id="4" name="">
             <a:extLst xmlns:a="http://schemas.openxmlformats.org/drawingml/2006/main">
               <a:ext uri="{FF2B5EF4-FFF2-40B4-BE49-F238E27FC236}">
-                <a16:creationId xmlns:a16="http://schemas.microsoft.com/office/drawing/2014/main" id="{6B9D819B-06F7-4CA4-8E33-88A85EFCE0CD}"/>
+                <a16:creationId xmlns:a16="http://schemas.microsoft.com/office/drawing/2014/main" id="{308C6511-1844-4E08-AC9A-4BF6C5986133}"/>
               </a:ext>
             </a:extLst>
           </p:cNvPr>
@@ -2202,21 +2202,21 @@
             <a:pPr>
               <a:defRPr sz="1875" b="0">
                 <a:solidFill>
-                  <a:srgbClr val="192D3D"/>
-                </a:solidFill>
-                <a:latin typeface="DejaVu Sans"/>
-                <a:ea typeface="DejaVu Sans"/>
-                <a:cs typeface="DejaVu Sans"/>
+                  <a:srgbClr val="262321"/>
+                </a:solidFill>
+                <a:latin typeface="Liberation Sans"/>
+                <a:ea typeface="Liberation Sans"/>
+                <a:cs typeface="Liberation Sans"/>
               </a:defRPr>
             </a:pPr>
             <a:r>
               <a:rPr sz="1875" b="0">
                 <a:solidFill>
-                  <a:srgbClr val="192D3D"/>
-                </a:solidFill>
-                <a:latin typeface="DejaVu Sans"/>
-                <a:ea typeface="DejaVu Sans"/>
-                <a:cs typeface="DejaVu Sans"/>
+                  <a:srgbClr val="262321"/>
+                </a:solidFill>
+                <a:latin typeface="Liberation Sans"/>
+                <a:ea typeface="Liberation Sans"/>
+                <a:cs typeface="Liberation Sans"/>
               </a:rPr>
               <a:t>Khadis Aidyn</a:t>
             </a:r>
@@ -2226,7 +2226,7 @@
     </p:spTree>
     <p:extLst>
       <p:ext uri="{BB962C8B-B14F-4D97-AF65-F5344CB8AC3E}">
-        <p14:creationId xmlns:p14="http://schemas.microsoft.com/office/powerpoint/2010/main" val="1937432384"/>
+        <p14:creationId xmlns:p14="http://schemas.microsoft.com/office/powerpoint/2010/main" val="1637571745"/>
       </p:ext>
     </p:extLst>
   </p:cSld>
@@ -2257,7 +2257,7 @@
           <p:cNvPr id="5" name="">
             <a:extLst xmlns:a="http://schemas.openxmlformats.org/drawingml/2006/main">
               <a:ext uri="{FF2B5EF4-FFF2-40B4-BE49-F238E27FC236}">
-                <a16:creationId xmlns:a16="http://schemas.microsoft.com/office/drawing/2014/main" id="{8A000E70-B6EE-4DE7-BBB1-3D9C5AAF4530}"/>
+                <a16:creationId xmlns:a16="http://schemas.microsoft.com/office/drawing/2014/main" id="{DD6A1A6D-0E38-4584-B9F0-A4AF426824CC}"/>
               </a:ext>
             </a:extLst>
           </p:cNvPr>
@@ -2288,21 +2288,21 @@
             <a:pPr>
               <a:defRPr sz="3300" b="1">
                 <a:solidFill>
-                  <a:srgbClr val="192D3D"/>
-                </a:solidFill>
-                <a:latin typeface="DejaVu Sans"/>
-                <a:ea typeface="DejaVu Sans"/>
-                <a:cs typeface="DejaVu Sans"/>
+                  <a:srgbClr val="262321"/>
+                </a:solidFill>
+                <a:latin typeface="Liberation Serif"/>
+                <a:ea typeface="Liberation Serif"/>
+                <a:cs typeface="Liberation Serif"/>
               </a:defRPr>
             </a:pPr>
             <a:r>
               <a:rPr sz="3300" b="1">
                 <a:solidFill>
-                  <a:srgbClr val="192D3D"/>
-                </a:solidFill>
-                <a:latin typeface="DejaVu Sans"/>
-                <a:ea typeface="DejaVu Sans"/>
-                <a:cs typeface="DejaVu Sans"/>
+                  <a:srgbClr val="262321"/>
+                </a:solidFill>
+                <a:latin typeface="Liberation Serif"/>
+                <a:ea typeface="Liberation Serif"/>
+                <a:cs typeface="Liberation Serif"/>
               </a:rPr>
               <a:t>Physical validity did not guarantee recovery</a:t>
             </a:r>
@@ -2314,7 +2314,7 @@
           <p:cNvPr id="2" name="">
             <a:extLst xmlns:a="http://schemas.openxmlformats.org/drawingml/2006/main">
               <a:ext uri="{FF2B5EF4-FFF2-40B4-BE49-F238E27FC236}">
-                <a16:creationId xmlns:a16="http://schemas.microsoft.com/office/drawing/2014/main" id="{7A70AEA4-A786-4BEE-A821-E714DC7E9B69}"/>
+                <a16:creationId xmlns:a16="http://schemas.microsoft.com/office/drawing/2014/main" id="{8F8BC91F-9E66-42E1-8C06-DF43C896CFE1}"/>
               </a:ext>
             </a:extLst>
           </p:cNvPr>
@@ -2345,21 +2345,21 @@
             <a:pPr>
               <a:defRPr sz="2025" b="0">
                 <a:solidFill>
-                  <a:srgbClr val="192D3D"/>
-                </a:solidFill>
-                <a:latin typeface="DejaVu Sans"/>
-                <a:ea typeface="DejaVu Sans"/>
-                <a:cs typeface="DejaVu Sans"/>
+                  <a:srgbClr val="262321"/>
+                </a:solidFill>
+                <a:latin typeface="Liberation Sans"/>
+                <a:ea typeface="Liberation Sans"/>
+                <a:cs typeface="Liberation Sans"/>
               </a:defRPr>
             </a:pPr>
             <a:r>
               <a:rPr sz="2025" b="0">
                 <a:solidFill>
-                  <a:srgbClr val="192D3D"/>
-                </a:solidFill>
-                <a:latin typeface="DejaVu Sans"/>
-                <a:ea typeface="DejaVu Sans"/>
-                <a:cs typeface="DejaVu Sans"/>
+                  <a:srgbClr val="262321"/>
+                </a:solidFill>
+                <a:latin typeface="Liberation Sans"/>
+                <a:ea typeface="Liberation Sans"/>
+                <a:cs typeface="Liberation Sans"/>
               </a:rPr>
               <a:t>All seven J1 joint failures missed the Q criterion.</a:t>
             </a:r>
@@ -2368,21 +2368,21 @@
             <a:pPr>
               <a:defRPr sz="2025" b="0">
                 <a:solidFill>
-                  <a:srgbClr val="192D3D"/>
-                </a:solidFill>
-                <a:latin typeface="DejaVu Sans"/>
-                <a:ea typeface="DejaVu Sans"/>
-                <a:cs typeface="DejaVu Sans"/>
+                  <a:srgbClr val="262321"/>
+                </a:solidFill>
+                <a:latin typeface="Liberation Sans"/>
+                <a:ea typeface="Liberation Sans"/>
+                <a:cs typeface="Liberation Sans"/>
               </a:defRPr>
             </a:pPr>
             <a:r>
               <a:rPr sz="2025" b="0">
                 <a:solidFill>
-                  <a:srgbClr val="192D3D"/>
-                </a:solidFill>
-                <a:latin typeface="DejaVu Sans"/>
-                <a:ea typeface="DejaVu Sans"/>
-                <a:cs typeface="DejaVu Sans"/>
+                  <a:srgbClr val="262321"/>
+                </a:solidFill>
+                <a:latin typeface="Liberation Sans"/>
+                <a:ea typeface="Liberation Sans"/>
+                <a:cs typeface="Liberation Sans"/>
               </a:rPr>
               <a:t>Development stopped after failed confirmation.</a:t>
             </a:r>
@@ -2391,21 +2391,21 @@
             <a:pPr>
               <a:defRPr sz="2025" b="0">
                 <a:solidFill>
-                  <a:srgbClr val="192D3D"/>
-                </a:solidFill>
-                <a:latin typeface="DejaVu Sans"/>
-                <a:ea typeface="DejaVu Sans"/>
-                <a:cs typeface="DejaVu Sans"/>
+                  <a:srgbClr val="262321"/>
+                </a:solidFill>
+                <a:latin typeface="Liberation Sans"/>
+                <a:ea typeface="Liberation Sans"/>
+                <a:cs typeface="Liberation Sans"/>
               </a:defRPr>
             </a:pPr>
             <a:r>
               <a:rPr sz="2025" b="0">
                 <a:solidFill>
-                  <a:srgbClr val="192D3D"/>
-                </a:solidFill>
-                <a:latin typeface="DejaVu Sans"/>
-                <a:ea typeface="DejaVu Sans"/>
-                <a:cs typeface="DejaVu Sans"/>
+                  <a:srgbClr val="262321"/>
+                </a:solidFill>
+                <a:latin typeface="Liberation Sans"/>
+                <a:ea typeface="Liberation Sans"/>
+                <a:cs typeface="Liberation Sans"/>
               </a:rPr>
               <a:t>Noise, uncertain weather and real Almaty attribution remain unvalidated.</a:t>
             </a:r>
@@ -2421,7 +2421,7 @@
           <p:nvPr/>
         </p:nvPicPr>
         <p:blipFill>
-          <a:blip xmlns:r="http://schemas.openxmlformats.org/officeDocument/2006/relationships" xmlns:a="http://schemas.openxmlformats.org/drawingml/2006/main" r:embed="R8c7ed084894045cb"/>
+          <a:blip xmlns:r="http://schemas.openxmlformats.org/officeDocument/2006/relationships" xmlns:a="http://schemas.openxmlformats.org/drawingml/2006/main" r:embed="R5bcb77279d374ca5"/>
           <a:stretch xmlns:a="http://schemas.openxmlformats.org/drawingml/2006/main"/>
         </p:blipFill>
         <p:spPr>
@@ -2439,7 +2439,7 @@
           <p:cNvPr id="4" name="">
             <a:extLst xmlns:a="http://schemas.openxmlformats.org/drawingml/2006/main">
               <a:ext uri="{FF2B5EF4-FFF2-40B4-BE49-F238E27FC236}">
-                <a16:creationId xmlns:a16="http://schemas.microsoft.com/office/drawing/2014/main" id="{B6AEAD33-A149-42B1-8B18-D5B138FD0F73}"/>
+                <a16:creationId xmlns:a16="http://schemas.microsoft.com/office/drawing/2014/main" id="{206B20F4-D7F8-456C-A398-0B568DF04428}"/>
               </a:ext>
             </a:extLst>
           </p:cNvPr>
@@ -2470,21 +2470,21 @@
             <a:pPr>
               <a:defRPr sz="1275" b="0">
                 <a:solidFill>
-                  <a:srgbClr val="61717B"/>
-                </a:solidFill>
-                <a:latin typeface="DejaVu Sans"/>
-                <a:ea typeface="DejaVu Sans"/>
-                <a:cs typeface="DejaVu Sans"/>
+                  <a:srgbClr val="716A65"/>
+                </a:solidFill>
+                <a:latin typeface="Liberation Sans"/>
+                <a:ea typeface="Liberation Sans"/>
+                <a:cs typeface="Liberation Sans"/>
               </a:defRPr>
             </a:pPr>
             <a:r>
               <a:rPr sz="1275" b="0">
                 <a:solidFill>
-                  <a:srgbClr val="61717B"/>
-                </a:solidFill>
-                <a:latin typeface="DejaVu Sans"/>
-                <a:ea typeface="DejaVu Sans"/>
-                <a:cs typeface="DejaVu Sans"/>
+                  <a:srgbClr val="716A65"/>
+                </a:solidFill>
+                <a:latin typeface="Liberation Sans"/>
+                <a:ea typeface="Liberation Sans"/>
+                <a:cs typeface="Liberation Sans"/>
               </a:rPr>
               <a:t>10</a:t>
             </a:r>
@@ -2494,7 +2494,7 @@
     </p:spTree>
     <p:extLst>
       <p:ext uri="{BB962C8B-B14F-4D97-AF65-F5344CB8AC3E}">
-        <p14:creationId xmlns:p14="http://schemas.microsoft.com/office/powerpoint/2010/main" val="519951943"/>
+        <p14:creationId xmlns:p14="http://schemas.microsoft.com/office/powerpoint/2010/main" val="445044465"/>
       </p:ext>
     </p:extLst>
   </p:cSld>
@@ -2525,7 +2525,7 @@
           <p:cNvPr id="5" name="">
             <a:extLst xmlns:a="http://schemas.openxmlformats.org/drawingml/2006/main">
               <a:ext uri="{FF2B5EF4-FFF2-40B4-BE49-F238E27FC236}">
-                <a16:creationId xmlns:a16="http://schemas.microsoft.com/office/drawing/2014/main" id="{80E64E21-1B48-4FE6-A4AD-1E75E7A7C7A0}"/>
+                <a16:creationId xmlns:a16="http://schemas.microsoft.com/office/drawing/2014/main" id="{DCD70350-56F6-4E26-833F-9435624F1184}"/>
               </a:ext>
             </a:extLst>
           </p:cNvPr>
@@ -2556,21 +2556,21 @@
             <a:pPr>
               <a:defRPr sz="3300" b="1">
                 <a:solidFill>
-                  <a:srgbClr val="192D3D"/>
-                </a:solidFill>
-                <a:latin typeface="DejaVu Sans"/>
-                <a:ea typeface="DejaVu Sans"/>
-                <a:cs typeface="DejaVu Sans"/>
+                  <a:srgbClr val="262321"/>
+                </a:solidFill>
+                <a:latin typeface="Liberation Serif"/>
+                <a:ea typeface="Liberation Serif"/>
+                <a:cs typeface="Liberation Serif"/>
               </a:defRPr>
             </a:pPr>
             <a:r>
               <a:rPr sz="3300" b="1">
                 <a:solidFill>
-                  <a:srgbClr val="192D3D"/>
-                </a:solidFill>
-                <a:latin typeface="DejaVu Sans"/>
-                <a:ea typeface="DejaVu Sans"/>
-                <a:cs typeface="DejaVu Sans"/>
+                  <a:srgbClr val="262321"/>
+                </a:solidFill>
+                <a:latin typeface="Liberation Serif"/>
+                <a:ea typeface="Liberation Serif"/>
+                <a:cs typeface="Liberation Serif"/>
               </a:rPr>
               <a:t>Sparse measurements, unknown source</a:t>
             </a:r>
@@ -2582,7 +2582,7 @@
           <p:cNvPr id="2" name="">
             <a:extLst xmlns:a="http://schemas.openxmlformats.org/drawingml/2006/main">
               <a:ext uri="{FF2B5EF4-FFF2-40B4-BE49-F238E27FC236}">
-                <a16:creationId xmlns:a16="http://schemas.microsoft.com/office/drawing/2014/main" id="{891D8279-D326-447C-869D-94255DCE6DD6}"/>
+                <a16:creationId xmlns:a16="http://schemas.microsoft.com/office/drawing/2014/main" id="{BAE873D6-2250-4013-8B12-2FB6FC3BEC1B}"/>
               </a:ext>
             </a:extLst>
           </p:cNvPr>
@@ -2613,21 +2613,21 @@
             <a:pPr>
               <a:defRPr sz="2700" b="0">
                 <a:solidFill>
-                  <a:srgbClr val="192D3D"/>
-                </a:solidFill>
-                <a:latin typeface="DejaVu Sans"/>
-                <a:ea typeface="DejaVu Sans"/>
-                <a:cs typeface="DejaVu Sans"/>
+                  <a:srgbClr val="262321"/>
+                </a:solidFill>
+                <a:latin typeface="Liberation Sans"/>
+                <a:ea typeface="Liberation Sans"/>
+                <a:cs typeface="Liberation Sans"/>
               </a:defRPr>
             </a:pPr>
             <a:r>
               <a:rPr sz="2700" b="0">
                 <a:solidFill>
-                  <a:srgbClr val="192D3D"/>
-                </a:solidFill>
-                <a:latin typeface="DejaVu Sans"/>
-                <a:ea typeface="DejaVu Sans"/>
-                <a:cs typeface="DejaVu Sans"/>
+                  <a:srgbClr val="262321"/>
+                </a:solidFill>
+                <a:latin typeface="Liberation Sans"/>
+                <a:ea typeface="Liberation Sans"/>
+                <a:cs typeface="Liberation Sans"/>
               </a:rPr>
               <a:t>Sensors observe concentration after transport.</a:t>
             </a:r>
@@ -2636,21 +2636,21 @@
             <a:pPr>
               <a:defRPr sz="2700" b="0">
                 <a:solidFill>
-                  <a:srgbClr val="192D3D"/>
-                </a:solidFill>
-                <a:latin typeface="DejaVu Sans"/>
-                <a:ea typeface="DejaVu Sans"/>
-                <a:cs typeface="DejaVu Sans"/>
+                  <a:srgbClr val="262321"/>
+                </a:solidFill>
+                <a:latin typeface="Liberation Sans"/>
+                <a:ea typeface="Liberation Sans"/>
+                <a:cs typeface="Liberation Sans"/>
               </a:defRPr>
             </a:pPr>
             <a:r>
               <a:rPr sz="2700" b="0">
                 <a:solidFill>
-                  <a:srgbClr val="192D3D"/>
-                </a:solidFill>
-                <a:latin typeface="DejaVu Sans"/>
-                <a:ea typeface="DejaVu Sans"/>
-                <a:cs typeface="DejaVu Sans"/>
+                  <a:srgbClr val="262321"/>
+                </a:solidFill>
+                <a:latin typeface="Liberation Sans"/>
+                <a:ea typeface="Liberation Sans"/>
+                <a:cs typeface="Liberation Sans"/>
               </a:rPr>
               <a:t>The unknowns are source location x_s, y_s and peak intensity Q.</a:t>
             </a:r>
@@ -2659,21 +2659,21 @@
             <a:pPr>
               <a:defRPr sz="2700" b="0">
                 <a:solidFill>
-                  <a:srgbClr val="192D3D"/>
-                </a:solidFill>
-                <a:latin typeface="DejaVu Sans"/>
-                <a:ea typeface="DejaVu Sans"/>
-                <a:cs typeface="DejaVu Sans"/>
+                  <a:srgbClr val="262321"/>
+                </a:solidFill>
+                <a:latin typeface="Liberation Sans"/>
+                <a:ea typeface="Liberation Sans"/>
+                <a:cs typeface="Liberation Sans"/>
               </a:defRPr>
             </a:pPr>
             <a:r>
               <a:rPr sz="2700" b="0">
                 <a:solidFill>
-                  <a:srgbClr val="192D3D"/>
-                </a:solidFill>
-                <a:latin typeface="DejaVu Sans"/>
-                <a:ea typeface="DejaVu Sans"/>
-                <a:cs typeface="DejaVu Sans"/>
+                  <a:srgbClr val="262321"/>
+                </a:solidFill>
+                <a:latin typeface="Liberation Sans"/>
+                <a:ea typeface="Liberation Sans"/>
+                <a:cs typeface="Liberation Sans"/>
               </a:rPr>
               <a:t>Almaty motivates the question; no real Almaty measurements enter this study.</a:t>
             </a:r>
@@ -2685,7 +2685,7 @@
           <p:cNvPr id="3" name="">
             <a:extLst xmlns:a="http://schemas.openxmlformats.org/drawingml/2006/main">
               <a:ext uri="{FF2B5EF4-FFF2-40B4-BE49-F238E27FC236}">
-                <a16:creationId xmlns:a16="http://schemas.microsoft.com/office/drawing/2014/main" id="{FFCF4470-1C29-423B-86B7-28A11C1C69FE}"/>
+                <a16:creationId xmlns:a16="http://schemas.microsoft.com/office/drawing/2014/main" id="{DB5BF44B-3A2E-4917-8662-A4EFB82DAA51}"/>
               </a:ext>
             </a:extLst>
           </p:cNvPr>
@@ -2716,21 +2716,21 @@
             <a:pPr>
               <a:defRPr sz="1800" b="0">
                 <a:solidFill>
-                  <a:srgbClr val="16688A"/>
-                </a:solidFill>
-                <a:latin typeface="DejaVu Sans"/>
-                <a:ea typeface="DejaVu Sans"/>
-                <a:cs typeface="DejaVu Sans"/>
+                  <a:srgbClr val="713E48"/>
+                </a:solidFill>
+                <a:latin typeface="Liberation Sans"/>
+                <a:ea typeface="Liberation Sans"/>
+                <a:cs typeface="Liberation Sans"/>
               </a:defRPr>
             </a:pPr>
             <a:r>
               <a:rPr sz="1800" b="0">
                 <a:solidFill>
-                  <a:srgbClr val="16688A"/>
-                </a:solidFill>
-                <a:latin typeface="DejaVu Sans"/>
-                <a:ea typeface="DejaVu Sans"/>
-                <a:cs typeface="DejaVu Sans"/>
+                  <a:srgbClr val="713E48"/>
+                </a:solidFill>
+                <a:latin typeface="Liberation Sans"/>
+                <a:ea typeface="Liberation Sans"/>
+                <a:cs typeface="Liberation Sans"/>
               </a:rPr>
               <a:t>20 fixed sensors.</a:t>
             </a:r>
@@ -2742,7 +2742,7 @@
           <p:cNvPr id="4" name="">
             <a:extLst xmlns:a="http://schemas.openxmlformats.org/drawingml/2006/main">
               <a:ext uri="{FF2B5EF4-FFF2-40B4-BE49-F238E27FC236}">
-                <a16:creationId xmlns:a16="http://schemas.microsoft.com/office/drawing/2014/main" id="{5544E663-E3FF-4B55-AA57-9A31F6C5DF3A}"/>
+                <a16:creationId xmlns:a16="http://schemas.microsoft.com/office/drawing/2014/main" id="{11F7ECC7-3493-4EFA-A82F-18A769124012}"/>
               </a:ext>
             </a:extLst>
           </p:cNvPr>
@@ -2773,21 +2773,21 @@
             <a:pPr>
               <a:defRPr sz="1275" b="0">
                 <a:solidFill>
-                  <a:srgbClr val="61717B"/>
-                </a:solidFill>
-                <a:latin typeface="DejaVu Sans"/>
-                <a:ea typeface="DejaVu Sans"/>
-                <a:cs typeface="DejaVu Sans"/>
+                  <a:srgbClr val="716A65"/>
+                </a:solidFill>
+                <a:latin typeface="Liberation Sans"/>
+                <a:ea typeface="Liberation Sans"/>
+                <a:cs typeface="Liberation Sans"/>
               </a:defRPr>
             </a:pPr>
             <a:r>
               <a:rPr sz="1275" b="0">
                 <a:solidFill>
-                  <a:srgbClr val="61717B"/>
-                </a:solidFill>
-                <a:latin typeface="DejaVu Sans"/>
-                <a:ea typeface="DejaVu Sans"/>
-                <a:cs typeface="DejaVu Sans"/>
+                  <a:srgbClr val="716A65"/>
+                </a:solidFill>
+                <a:latin typeface="Liberation Sans"/>
+                <a:ea typeface="Liberation Sans"/>
+                <a:cs typeface="Liberation Sans"/>
               </a:rPr>
               <a:t>2</a:t>
             </a:r>
@@ -2797,7 +2797,7 @@
     </p:spTree>
     <p:extLst>
       <p:ext uri="{BB962C8B-B14F-4D97-AF65-F5344CB8AC3E}">
-        <p14:creationId xmlns:p14="http://schemas.microsoft.com/office/powerpoint/2010/main" val="70621119"/>
+        <p14:creationId xmlns:p14="http://schemas.microsoft.com/office/powerpoint/2010/main" val="1961802148"/>
       </p:ext>
     </p:extLst>
   </p:cSld>
@@ -2828,7 +2828,7 @@
           <p:cNvPr id="5" name="">
             <a:extLst xmlns:a="http://schemas.openxmlformats.org/drawingml/2006/main">
               <a:ext uri="{FF2B5EF4-FFF2-40B4-BE49-F238E27FC236}">
-                <a16:creationId xmlns:a16="http://schemas.microsoft.com/office/drawing/2014/main" id="{E7530217-309F-42D3-BA4C-60B524E8B607}"/>
+                <a16:creationId xmlns:a16="http://schemas.microsoft.com/office/drawing/2014/main" id="{2B346FE6-42D0-4046-948A-5F814B3D54B7}"/>
               </a:ext>
             </a:extLst>
           </p:cNvPr>
@@ -2859,21 +2859,21 @@
             <a:pPr>
               <a:defRPr sz="3300" b="1">
                 <a:solidFill>
-                  <a:srgbClr val="192D3D"/>
-                </a:solidFill>
-                <a:latin typeface="DejaVu Sans"/>
-                <a:ea typeface="DejaVu Sans"/>
-                <a:cs typeface="DejaVu Sans"/>
+                  <a:srgbClr val="262321"/>
+                </a:solidFill>
+                <a:latin typeface="Liberation Serif"/>
+                <a:ea typeface="Liberation Serif"/>
+                <a:cs typeface="Liberation Serif"/>
               </a:defRPr>
             </a:pPr>
             <a:r>
               <a:rPr sz="3300" b="1">
                 <a:solidFill>
-                  <a:srgbClr val="192D3D"/>
-                </a:solidFill>
-                <a:latin typeface="DejaVu Sans"/>
-                <a:ea typeface="DejaVu Sans"/>
-                <a:cs typeface="DejaVu Sans"/>
+                  <a:srgbClr val="262321"/>
+                </a:solidFill>
+                <a:latin typeface="Liberation Serif"/>
+                <a:ea typeface="Liberation Serif"/>
+                <a:cs typeface="Liberation Serif"/>
               </a:rPr>
               <a:t>Known transport physics</a:t>
             </a:r>
@@ -2885,7 +2885,7 @@
           <p:cNvPr id="2" name="">
             <a:extLst xmlns:a="http://schemas.openxmlformats.org/drawingml/2006/main">
               <a:ext uri="{FF2B5EF4-FFF2-40B4-BE49-F238E27FC236}">
-                <a16:creationId xmlns:a16="http://schemas.microsoft.com/office/drawing/2014/main" id="{41BBA372-128B-4EF7-A0E7-6D2F88A382A0}"/>
+                <a16:creationId xmlns:a16="http://schemas.microsoft.com/office/drawing/2014/main" id="{44CABD7A-5B26-4D2F-A37E-FA047F03E6F1}"/>
               </a:ext>
             </a:extLst>
           </p:cNvPr>
@@ -2916,21 +2916,21 @@
             <a:pPr>
               <a:defRPr sz="2550" b="0">
                 <a:solidFill>
-                  <a:srgbClr val="192D3D"/>
-                </a:solidFill>
-                <a:latin typeface="DejaVu Sans"/>
-                <a:ea typeface="DejaVu Sans"/>
-                <a:cs typeface="DejaVu Sans"/>
+                  <a:srgbClr val="262321"/>
+                </a:solidFill>
+                <a:latin typeface="Liberation Sans"/>
+                <a:ea typeface="Liberation Sans"/>
+                <a:cs typeface="Liberation Sans"/>
               </a:defRPr>
             </a:pPr>
             <a:r>
               <a:rPr sz="2550" b="0">
                 <a:solidFill>
-                  <a:srgbClr val="192D3D"/>
-                </a:solidFill>
-                <a:latin typeface="DejaVu Sans"/>
-                <a:ea typeface="DejaVu Sans"/>
-                <a:cs typeface="DejaVu Sans"/>
+                  <a:srgbClr val="262321"/>
+                </a:solidFill>
+                <a:latin typeface="Liberation Sans"/>
+                <a:ea typeface="Liberation Sans"/>
+                <a:cs typeface="Liberation Sans"/>
               </a:rPr>
               <a:t>C_t + u C_x + v C_y = D(C_xx + C_yy) + QG</a:t>
             </a:r>
@@ -2944,21 +2944,21 @@
             <a:pPr>
               <a:defRPr sz="2550" b="0">
                 <a:solidFill>
-                  <a:srgbClr val="192D3D"/>
-                </a:solidFill>
-                <a:latin typeface="DejaVu Sans"/>
-                <a:ea typeface="DejaVu Sans"/>
-                <a:cs typeface="DejaVu Sans"/>
+                  <a:srgbClr val="262321"/>
+                </a:solidFill>
+                <a:latin typeface="Liberation Sans"/>
+                <a:ea typeface="Liberation Sans"/>
+                <a:cs typeface="Liberation Sans"/>
               </a:defRPr>
             </a:pPr>
             <a:r>
               <a:rPr sz="2550" b="0">
                 <a:solidFill>
-                  <a:srgbClr val="192D3D"/>
-                </a:solidFill>
-                <a:latin typeface="DejaVu Sans"/>
-                <a:ea typeface="DejaVu Sans"/>
-                <a:cs typeface="DejaVu Sans"/>
+                  <a:srgbClr val="262321"/>
+                </a:solidFill>
+                <a:latin typeface="Liberation Sans"/>
+                <a:ea typeface="Liberation Sans"/>
+                <a:cs typeface="Liberation Sans"/>
               </a:rPr>
               <a:t>Wind carries concentration; diffusion spreads it; the source adds it.</a:t>
             </a:r>
@@ -2967,21 +2967,21 @@
             <a:pPr>
               <a:defRPr sz="2550" b="0">
                 <a:solidFill>
-                  <a:srgbClr val="192D3D"/>
-                </a:solidFill>
-                <a:latin typeface="DejaVu Sans"/>
-                <a:ea typeface="DejaVu Sans"/>
-                <a:cs typeface="DejaVu Sans"/>
+                  <a:srgbClr val="262321"/>
+                </a:solidFill>
+                <a:latin typeface="Liberation Sans"/>
+                <a:ea typeface="Liberation Sans"/>
+                <a:cs typeface="Liberation Sans"/>
               </a:defRPr>
             </a:pPr>
             <a:r>
               <a:rPr sz="2550" b="0">
                 <a:solidFill>
-                  <a:srgbClr val="192D3D"/>
-                </a:solidFill>
-                <a:latin typeface="DejaVu Sans"/>
-                <a:ea typeface="DejaVu Sans"/>
-                <a:cs typeface="DejaVu Sans"/>
+                  <a:srgbClr val="262321"/>
+                </a:solidFill>
+                <a:latin typeface="Liberation Sans"/>
+                <a:ea typeface="Liberation Sans"/>
+                <a:cs typeface="Liberation Sans"/>
               </a:rPr>
               <a:t>One Gaussian, known width and transport. Zero initial and boundary concentration.</a:t>
             </a:r>
@@ -2993,7 +2993,7 @@
           <p:cNvPr id="3" name="">
             <a:extLst xmlns:a="http://schemas.openxmlformats.org/drawingml/2006/main">
               <a:ext uri="{FF2B5EF4-FFF2-40B4-BE49-F238E27FC236}">
-                <a16:creationId xmlns:a16="http://schemas.microsoft.com/office/drawing/2014/main" id="{3387913C-A3F8-4B5E-A398-35DD4CA418FB}"/>
+                <a16:creationId xmlns:a16="http://schemas.microsoft.com/office/drawing/2014/main" id="{D4530CCB-8E6A-4A98-B52C-E43F8DDA8F80}"/>
               </a:ext>
             </a:extLst>
           </p:cNvPr>
@@ -3024,21 +3024,21 @@
             <a:pPr>
               <a:defRPr sz="1725" b="0">
                 <a:solidFill>
-                  <a:srgbClr val="16688A"/>
-                </a:solidFill>
-                <a:latin typeface="DejaVu Sans"/>
-                <a:ea typeface="DejaVu Sans"/>
-                <a:cs typeface="DejaVu Sans"/>
+                  <a:srgbClr val="713E48"/>
+                </a:solidFill>
+                <a:latin typeface="Liberation Sans"/>
+                <a:ea typeface="Liberation Sans"/>
+                <a:cs typeface="Liberation Sans"/>
               </a:defRPr>
             </a:pPr>
             <a:r>
               <a:rPr sz="1725" b="0">
                 <a:solidFill>
-                  <a:srgbClr val="16688A"/>
-                </a:solidFill>
-                <a:latin typeface="DejaVu Sans"/>
-                <a:ea typeface="DejaVu Sans"/>
-                <a:cs typeface="DejaVu Sans"/>
+                  <a:srgbClr val="713E48"/>
+                </a:solidFill>
+                <a:latin typeface="Liberation Sans"/>
+                <a:ea typeface="Liberation Sans"/>
+                <a:cs typeface="Liberation Sans"/>
               </a:rPr>
               <a:t>u=0.35, v=-0.15, D=0.005, sigma=0.08.</a:t>
             </a:r>
@@ -3050,7 +3050,7 @@
           <p:cNvPr id="4" name="">
             <a:extLst xmlns:a="http://schemas.openxmlformats.org/drawingml/2006/main">
               <a:ext uri="{FF2B5EF4-FFF2-40B4-BE49-F238E27FC236}">
-                <a16:creationId xmlns:a16="http://schemas.microsoft.com/office/drawing/2014/main" id="{B859A16B-1851-449E-8E46-0AE807F5D0A3}"/>
+                <a16:creationId xmlns:a16="http://schemas.microsoft.com/office/drawing/2014/main" id="{AFF15338-A1EC-4E98-9ECA-9A6A38F5690B}"/>
               </a:ext>
             </a:extLst>
           </p:cNvPr>
@@ -3081,21 +3081,21 @@
             <a:pPr>
               <a:defRPr sz="1275" b="0">
                 <a:solidFill>
-                  <a:srgbClr val="61717B"/>
-                </a:solidFill>
-                <a:latin typeface="DejaVu Sans"/>
-                <a:ea typeface="DejaVu Sans"/>
-                <a:cs typeface="DejaVu Sans"/>
+                  <a:srgbClr val="716A65"/>
+                </a:solidFill>
+                <a:latin typeface="Liberation Sans"/>
+                <a:ea typeface="Liberation Sans"/>
+                <a:cs typeface="Liberation Sans"/>
               </a:defRPr>
             </a:pPr>
             <a:r>
               <a:rPr sz="1275" b="0">
                 <a:solidFill>
-                  <a:srgbClr val="61717B"/>
-                </a:solidFill>
-                <a:latin typeface="DejaVu Sans"/>
-                <a:ea typeface="DejaVu Sans"/>
-                <a:cs typeface="DejaVu Sans"/>
+                  <a:srgbClr val="716A65"/>
+                </a:solidFill>
+                <a:latin typeface="Liberation Sans"/>
+                <a:ea typeface="Liberation Sans"/>
+                <a:cs typeface="Liberation Sans"/>
               </a:rPr>
               <a:t>3</a:t>
             </a:r>
@@ -3105,7 +3105,7 @@
     </p:spTree>
     <p:extLst>
       <p:ext uri="{BB962C8B-B14F-4D97-AF65-F5344CB8AC3E}">
-        <p14:creationId xmlns:p14="http://schemas.microsoft.com/office/powerpoint/2010/main" val="612700839"/>
+        <p14:creationId xmlns:p14="http://schemas.microsoft.com/office/powerpoint/2010/main" val="579932015"/>
       </p:ext>
     </p:extLst>
   </p:cSld>
@@ -3136,7 +3136,7 @@
           <p:cNvPr id="5" name="">
             <a:extLst xmlns:a="http://schemas.openxmlformats.org/drawingml/2006/main">
               <a:ext uri="{FF2B5EF4-FFF2-40B4-BE49-F238E27FC236}">
-                <a16:creationId xmlns:a16="http://schemas.microsoft.com/office/drawing/2014/main" id="{A6B87B79-3B0B-4324-897C-B502D0A9B0E8}"/>
+                <a16:creationId xmlns:a16="http://schemas.microsoft.com/office/drawing/2014/main" id="{3A19DC0D-DE43-4837-A091-1605512F6D7B}"/>
               </a:ext>
             </a:extLst>
           </p:cNvPr>
@@ -3167,21 +3167,21 @@
             <a:pPr>
               <a:defRPr sz="3300" b="1">
                 <a:solidFill>
-                  <a:srgbClr val="192D3D"/>
-                </a:solidFill>
-                <a:latin typeface="DejaVu Sans"/>
-                <a:ea typeface="DejaVu Sans"/>
-                <a:cs typeface="DejaVu Sans"/>
+                  <a:srgbClr val="262321"/>
+                </a:solidFill>
+                <a:latin typeface="Liberation Serif"/>
+                <a:ea typeface="Liberation Serif"/>
+                <a:cs typeface="Liberation Serif"/>
               </a:defRPr>
             </a:pPr>
             <a:r>
               <a:rPr sz="3300" b="1">
                 <a:solidFill>
-                  <a:srgbClr val="192D3D"/>
-                </a:solidFill>
-                <a:latin typeface="DejaVu Sans"/>
-                <a:ea typeface="DejaVu Sans"/>
-                <a:cs typeface="DejaVu Sans"/>
+                  <a:srgbClr val="262321"/>
+                </a:solidFill>
+                <a:latin typeface="Liberation Serif"/>
+                <a:ea typeface="Liberation Serif"/>
+                <a:cs typeface="Liberation Serif"/>
               </a:rPr>
               <a:t>Neural field and source inference</a:t>
             </a:r>
@@ -3193,7 +3193,7 @@
           <p:cNvPr id="2" name="">
             <a:extLst xmlns:a="http://schemas.openxmlformats.org/drawingml/2006/main">
               <a:ext uri="{FF2B5EF4-FFF2-40B4-BE49-F238E27FC236}">
-                <a16:creationId xmlns:a16="http://schemas.microsoft.com/office/drawing/2014/main" id="{CC07A8B6-8913-4F28-9BAB-B0E1D4D4BA35}"/>
+                <a16:creationId xmlns:a16="http://schemas.microsoft.com/office/drawing/2014/main" id="{F1675948-556D-4A46-9644-9862B0A37BB3}"/>
               </a:ext>
             </a:extLst>
           </p:cNvPr>
@@ -3224,21 +3224,21 @@
             <a:pPr>
               <a:defRPr sz="2025" b="0">
                 <a:solidFill>
-                  <a:srgbClr val="192D3D"/>
-                </a:solidFill>
-                <a:latin typeface="DejaVu Sans"/>
-                <a:ea typeface="DejaVu Sans"/>
-                <a:cs typeface="DejaVu Sans"/>
+                  <a:srgbClr val="262321"/>
+                </a:solidFill>
+                <a:latin typeface="Liberation Sans"/>
+                <a:ea typeface="Liberation Sans"/>
+                <a:cs typeface="Liberation Sans"/>
               </a:defRPr>
             </a:pPr>
             <a:r>
               <a:rPr sz="2025" b="0">
                 <a:solidFill>
-                  <a:srgbClr val="192D3D"/>
-                </a:solidFill>
-                <a:latin typeface="DejaVu Sans"/>
-                <a:ea typeface="DejaVu Sans"/>
-                <a:cs typeface="DejaVu Sans"/>
+                  <a:srgbClr val="262321"/>
+                </a:solidFill>
+                <a:latin typeface="Liberation Sans"/>
+                <a:ea typeface="Liberation Sans"/>
+                <a:cs typeface="Liberation Sans"/>
               </a:rPr>
               <a:t>A PyTorch network represents C(x,y,t).</a:t>
             </a:r>
@@ -3247,21 +3247,21 @@
             <a:pPr>
               <a:defRPr sz="2025" b="0">
                 <a:solidFill>
-                  <a:srgbClr val="192D3D"/>
-                </a:solidFill>
-                <a:latin typeface="DejaVu Sans"/>
-                <a:ea typeface="DejaVu Sans"/>
-                <a:cs typeface="DejaVu Sans"/>
+                  <a:srgbClr val="262321"/>
+                </a:solidFill>
+                <a:latin typeface="Liberation Sans"/>
+                <a:ea typeface="Liberation Sans"/>
+                <a:cs typeface="Liberation Sans"/>
               </a:defRPr>
             </a:pPr>
             <a:r>
               <a:rPr sz="2025" b="0">
                 <a:solidFill>
-                  <a:srgbClr val="192D3D"/>
-                </a:solidFill>
-                <a:latin typeface="DejaVu Sans"/>
-                <a:ea typeface="DejaVu Sans"/>
-                <a:cs typeface="DejaVu Sans"/>
+                  <a:srgbClr val="262321"/>
+                </a:solidFill>
+                <a:latin typeface="Liberation Sans"/>
+                <a:ea typeface="Liberation Sans"/>
+                <a:cs typeface="Liberation Sans"/>
               </a:rPr>
               <a:t>Sensor loss fits observations; PDE residual couples the field to the source.</a:t>
             </a:r>
@@ -3270,21 +3270,21 @@
             <a:pPr>
               <a:defRPr sz="2025" b="0">
                 <a:solidFill>
-                  <a:srgbClr val="192D3D"/>
-                </a:solidFill>
-                <a:latin typeface="DejaVu Sans"/>
-                <a:ea typeface="DejaVu Sans"/>
-                <a:cs typeface="DejaVu Sans"/>
+                  <a:srgbClr val="262321"/>
+                </a:solidFill>
+                <a:latin typeface="Liberation Sans"/>
+                <a:ea typeface="Liberation Sans"/>
+                <a:cs typeface="Liberation Sans"/>
               </a:defRPr>
             </a:pPr>
             <a:r>
               <a:rPr sz="2025" b="0">
                 <a:solidFill>
-                  <a:srgbClr val="192D3D"/>
-                </a:solidFill>
-                <a:latin typeface="DejaVu Sans"/>
-                <a:ea typeface="DejaVu Sans"/>
-                <a:cs typeface="DejaVu Sans"/>
+                  <a:srgbClr val="262321"/>
+                </a:solidFill>
+                <a:latin typeface="Liberation Sans"/>
+                <a:ea typeface="Liberation Sans"/>
+                <a:cs typeface="Liberation Sans"/>
               </a:rPr>
               <a:t>Hard constraints enforce nonnegative concentration and exact zero IC/BC.</a:t>
             </a:r>
@@ -3300,7 +3300,7 @@
           <p:nvPr/>
         </p:nvPicPr>
         <p:blipFill>
-          <a:blip xmlns:r="http://schemas.openxmlformats.org/officeDocument/2006/relationships" xmlns:a="http://schemas.openxmlformats.org/drawingml/2006/main" r:embed="R9ecf00e3437d4f09"/>
+          <a:blip xmlns:r="http://schemas.openxmlformats.org/officeDocument/2006/relationships" xmlns:a="http://schemas.openxmlformats.org/drawingml/2006/main" r:embed="Rc9c4e540c2e94331"/>
           <a:stretch xmlns:a="http://schemas.openxmlformats.org/drawingml/2006/main"/>
         </p:blipFill>
         <p:spPr>
@@ -3318,7 +3318,7 @@
           <p:cNvPr id="4" name="">
             <a:extLst xmlns:a="http://schemas.openxmlformats.org/drawingml/2006/main">
               <a:ext uri="{FF2B5EF4-FFF2-40B4-BE49-F238E27FC236}">
-                <a16:creationId xmlns:a16="http://schemas.microsoft.com/office/drawing/2014/main" id="{178AAC63-6CD4-44A1-A21E-3604E88D3BFC}"/>
+                <a16:creationId xmlns:a16="http://schemas.microsoft.com/office/drawing/2014/main" id="{13D82761-CEF7-4E69-A5E9-FF9B8550EE58}"/>
               </a:ext>
             </a:extLst>
           </p:cNvPr>
@@ -3349,21 +3349,21 @@
             <a:pPr>
               <a:defRPr sz="1275" b="0">
                 <a:solidFill>
-                  <a:srgbClr val="61717B"/>
-                </a:solidFill>
-                <a:latin typeface="DejaVu Sans"/>
-                <a:ea typeface="DejaVu Sans"/>
-                <a:cs typeface="DejaVu Sans"/>
+                  <a:srgbClr val="716A65"/>
+                </a:solidFill>
+                <a:latin typeface="Liberation Sans"/>
+                <a:ea typeface="Liberation Sans"/>
+                <a:cs typeface="Liberation Sans"/>
               </a:defRPr>
             </a:pPr>
             <a:r>
               <a:rPr sz="1275" b="0">
                 <a:solidFill>
-                  <a:srgbClr val="61717B"/>
-                </a:solidFill>
-                <a:latin typeface="DejaVu Sans"/>
-                <a:ea typeface="DejaVu Sans"/>
-                <a:cs typeface="DejaVu Sans"/>
+                  <a:srgbClr val="716A65"/>
+                </a:solidFill>
+                <a:latin typeface="Liberation Sans"/>
+                <a:ea typeface="Liberation Sans"/>
+                <a:cs typeface="Liberation Sans"/>
               </a:rPr>
               <a:t>4</a:t>
             </a:r>
@@ -3373,7 +3373,7 @@
     </p:spTree>
     <p:extLst>
       <p:ext uri="{BB962C8B-B14F-4D97-AF65-F5344CB8AC3E}">
-        <p14:creationId xmlns:p14="http://schemas.microsoft.com/office/powerpoint/2010/main" val="552895232"/>
+        <p14:creationId xmlns:p14="http://schemas.microsoft.com/office/powerpoint/2010/main" val="817534157"/>
       </p:ext>
     </p:extLst>
   </p:cSld>
@@ -3404,7 +3404,7 @@
           <p:cNvPr id="5" name="">
             <a:extLst xmlns:a="http://schemas.openxmlformats.org/drawingml/2006/main">
               <a:ext uri="{FF2B5EF4-FFF2-40B4-BE49-F238E27FC236}">
-                <a16:creationId xmlns:a16="http://schemas.microsoft.com/office/drawing/2014/main" id="{A1543681-A379-4364-B5E5-44FC493C7ABB}"/>
+                <a16:creationId xmlns:a16="http://schemas.microsoft.com/office/drawing/2014/main" id="{A5E8F274-338C-40B2-9A4D-89B2CF769E62}"/>
               </a:ext>
             </a:extLst>
           </p:cNvPr>
@@ -3435,21 +3435,21 @@
             <a:pPr>
               <a:defRPr sz="3300" b="1">
                 <a:solidFill>
-                  <a:srgbClr val="192D3D"/>
-                </a:solidFill>
-                <a:latin typeface="DejaVu Sans"/>
-                <a:ea typeface="DejaVu Sans"/>
-                <a:cs typeface="DejaVu Sans"/>
+                  <a:srgbClr val="262321"/>
+                </a:solidFill>
+                <a:latin typeface="Liberation Serif"/>
+                <a:ea typeface="Liberation Serif"/>
+                <a:cs typeface="Liberation Serif"/>
               </a:defRPr>
             </a:pPr>
             <a:r>
               <a:rPr sz="3300" b="1">
                 <a:solidFill>
-                  <a:srgbClr val="192D3D"/>
-                </a:solidFill>
-                <a:latin typeface="DejaVu Sans"/>
-                <a:ea typeface="DejaVu Sans"/>
-                <a:cs typeface="DejaVu Sans"/>
+                  <a:srgbClr val="262321"/>
+                </a:solidFill>
+                <a:latin typeface="Liberation Serif"/>
+                <a:ea typeface="Liberation Serif"/>
+                <a:cs typeface="Liberation Serif"/>
               </a:rPr>
               <a:t>Reference quality and blind evaluation</a:t>
             </a:r>
@@ -3461,7 +3461,7 @@
           <p:cNvPr id="2" name="">
             <a:extLst xmlns:a="http://schemas.openxmlformats.org/drawingml/2006/main">
               <a:ext uri="{FF2B5EF4-FFF2-40B4-BE49-F238E27FC236}">
-                <a16:creationId xmlns:a16="http://schemas.microsoft.com/office/drawing/2014/main" id="{493703D0-32C0-4613-96F0-9687652E4783}"/>
+                <a16:creationId xmlns:a16="http://schemas.microsoft.com/office/drawing/2014/main" id="{4B3AF492-F25F-4BE5-B52E-B6120D4B0BD0}"/>
               </a:ext>
             </a:extLst>
           </p:cNvPr>
@@ -3492,21 +3492,21 @@
             <a:pPr>
               <a:defRPr sz="2175" b="0">
                 <a:solidFill>
-                  <a:srgbClr val="192D3D"/>
-                </a:solidFill>
-                <a:latin typeface="DejaVu Sans"/>
-                <a:ea typeface="DejaVu Sans"/>
-                <a:cs typeface="DejaVu Sans"/>
+                  <a:srgbClr val="262321"/>
+                </a:solidFill>
+                <a:latin typeface="Liberation Sans"/>
+                <a:ea typeface="Liberation Sans"/>
+                <a:cs typeface="Liberation Sans"/>
               </a:defRPr>
             </a:pPr>
             <a:r>
               <a:rPr sz="2175" b="0">
                 <a:solidFill>
-                  <a:srgbClr val="192D3D"/>
-                </a:solidFill>
-                <a:latin typeface="DejaVu Sans"/>
-                <a:ea typeface="DejaVu Sans"/>
-                <a:cs typeface="DejaVu Sans"/>
+                  <a:srgbClr val="262321"/>
+                </a:solidFill>
+                <a:latin typeface="Liberation Sans"/>
+                <a:ea typeface="Liberation Sans"/>
+                <a:cs typeface="Liberation Sans"/>
               </a:rPr>
               <a:t>641×641 numerical reference · 30 fresh final scenarios</a:t>
             </a:r>
@@ -3515,21 +3515,21 @@
             <a:pPr>
               <a:defRPr sz="2175" b="0">
                 <a:solidFill>
-                  <a:srgbClr val="192D3D"/>
-                </a:solidFill>
-                <a:latin typeface="DejaVu Sans"/>
-                <a:ea typeface="DejaVu Sans"/>
-                <a:cs typeface="DejaVu Sans"/>
+                  <a:srgbClr val="262321"/>
+                </a:solidFill>
+                <a:latin typeface="Liberation Sans"/>
+                <a:ea typeface="Liberation Sans"/>
+                <a:cs typeface="Liberation Sans"/>
               </a:defRPr>
             </a:pPr>
             <a:r>
               <a:rPr sz="2175" b="0">
                 <a:solidFill>
-                  <a:srgbClr val="192D3D"/>
-                </a:solidFill>
-                <a:latin typeface="DejaVu Sans"/>
-                <a:ea typeface="DejaVu Sans"/>
-                <a:cs typeface="DejaVu Sans"/>
+                  <a:srgbClr val="262321"/>
+                </a:solidFill>
+                <a:latin typeface="Liberation Sans"/>
+                <a:ea typeface="Liberation Sans"/>
+                <a:cs typeface="Liberation Sans"/>
               </a:rPr>
               <a:t>Frozen methods and thresholds; all failures retained</a:t>
             </a:r>
@@ -3545,7 +3545,7 @@
           <p:nvPr/>
         </p:nvPicPr>
         <p:blipFill>
-          <a:blip xmlns:r="http://schemas.openxmlformats.org/officeDocument/2006/relationships" xmlns:a="http://schemas.openxmlformats.org/drawingml/2006/main" r:embed="Rbf6b9bf96518402e"/>
+          <a:blip xmlns:r="http://schemas.openxmlformats.org/officeDocument/2006/relationships" xmlns:a="http://schemas.openxmlformats.org/drawingml/2006/main" r:embed="R8715d1b579e14151"/>
           <a:stretch xmlns:a="http://schemas.openxmlformats.org/drawingml/2006/main"/>
         </p:blipFill>
         <p:spPr>
@@ -3563,7 +3563,7 @@
           <p:cNvPr id="4" name="">
             <a:extLst xmlns:a="http://schemas.openxmlformats.org/drawingml/2006/main">
               <a:ext uri="{FF2B5EF4-FFF2-40B4-BE49-F238E27FC236}">
-                <a16:creationId xmlns:a16="http://schemas.microsoft.com/office/drawing/2014/main" id="{6F5A9C3A-85A0-4AFB-B1A7-2D0E9C9A256F}"/>
+                <a16:creationId xmlns:a16="http://schemas.microsoft.com/office/drawing/2014/main" id="{35530669-8FB1-4B24-BFDC-D182B52A2B1C}"/>
               </a:ext>
             </a:extLst>
           </p:cNvPr>
@@ -3594,21 +3594,21 @@
             <a:pPr>
               <a:defRPr sz="1275" b="0">
                 <a:solidFill>
-                  <a:srgbClr val="61717B"/>
-                </a:solidFill>
-                <a:latin typeface="DejaVu Sans"/>
-                <a:ea typeface="DejaVu Sans"/>
-                <a:cs typeface="DejaVu Sans"/>
+                  <a:srgbClr val="716A65"/>
+                </a:solidFill>
+                <a:latin typeface="Liberation Sans"/>
+                <a:ea typeface="Liberation Sans"/>
+                <a:cs typeface="Liberation Sans"/>
               </a:defRPr>
             </a:pPr>
             <a:r>
               <a:rPr sz="1275" b="0">
                 <a:solidFill>
-                  <a:srgbClr val="61717B"/>
-                </a:solidFill>
-                <a:latin typeface="DejaVu Sans"/>
-                <a:ea typeface="DejaVu Sans"/>
-                <a:cs typeface="DejaVu Sans"/>
+                  <a:srgbClr val="716A65"/>
+                </a:solidFill>
+                <a:latin typeface="Liberation Sans"/>
+                <a:ea typeface="Liberation Sans"/>
+                <a:cs typeface="Liberation Sans"/>
               </a:rPr>
               <a:t>5</a:t>
             </a:r>
@@ -3618,7 +3618,7 @@
     </p:spTree>
     <p:extLst>
       <p:ext uri="{BB962C8B-B14F-4D97-AF65-F5344CB8AC3E}">
-        <p14:creationId xmlns:p14="http://schemas.microsoft.com/office/powerpoint/2010/main" val="1508774330"/>
+        <p14:creationId xmlns:p14="http://schemas.microsoft.com/office/powerpoint/2010/main" val="142378804"/>
       </p:ext>
     </p:extLst>
   </p:cSld>
@@ -3649,7 +3649,7 @@
           <p:cNvPr id="5" name="">
             <a:extLst xmlns:a="http://schemas.openxmlformats.org/drawingml/2006/main">
               <a:ext uri="{FF2B5EF4-FFF2-40B4-BE49-F238E27FC236}">
-                <a16:creationId xmlns:a16="http://schemas.microsoft.com/office/drawing/2014/main" id="{CEB49800-B420-44F6-AC45-80E0728F5D68}"/>
+                <a16:creationId xmlns:a16="http://schemas.microsoft.com/office/drawing/2014/main" id="{F6FC512D-F609-48BB-8C93-3ECCF57AB7D4}"/>
               </a:ext>
             </a:extLst>
           </p:cNvPr>
@@ -3680,21 +3680,21 @@
             <a:pPr>
               <a:defRPr sz="3300" b="1">
                 <a:solidFill>
-                  <a:srgbClr val="192D3D"/>
-                </a:solidFill>
-                <a:latin typeface="DejaVu Sans"/>
-                <a:ea typeface="DejaVu Sans"/>
-                <a:cs typeface="DejaVu Sans"/>
+                  <a:srgbClr val="262321"/>
+                </a:solidFill>
+                <a:latin typeface="Liberation Serif"/>
+                <a:ea typeface="Liberation Serif"/>
+                <a:cs typeface="Liberation Serif"/>
               </a:defRPr>
             </a:pPr>
             <a:r>
               <a:rPr sz="3300" b="1">
                 <a:solidFill>
-                  <a:srgbClr val="192D3D"/>
-                </a:solidFill>
-                <a:latin typeface="DejaVu Sans"/>
-                <a:ea typeface="DejaVu Sans"/>
-                <a:cs typeface="DejaVu Sans"/>
+                  <a:srgbClr val="262321"/>
+                </a:solidFill>
+                <a:latin typeface="Liberation Serif"/>
+                <a:ea typeface="Liberation Serif"/>
+                <a:cs typeface="Liberation Serif"/>
               </a:rPr>
               <a:t>Early failure and persistent Q bias</a:t>
             </a:r>
@@ -3706,7 +3706,7 @@
           <p:cNvPr id="2" name="">
             <a:extLst xmlns:a="http://schemas.openxmlformats.org/drawingml/2006/main">
               <a:ext uri="{FF2B5EF4-FFF2-40B4-BE49-F238E27FC236}">
-                <a16:creationId xmlns:a16="http://schemas.microsoft.com/office/drawing/2014/main" id="{B79DC9CC-0307-4870-95D8-496013A6A2C5}"/>
+                <a16:creationId xmlns:a16="http://schemas.microsoft.com/office/drawing/2014/main" id="{C0642976-C543-4EC0-AB61-7B199A1188AD}"/>
               </a:ext>
             </a:extLst>
           </p:cNvPr>
@@ -3737,21 +3737,21 @@
             <a:pPr>
               <a:defRPr sz="2700" b="0">
                 <a:solidFill>
-                  <a:srgbClr val="192D3D"/>
-                </a:solidFill>
-                <a:latin typeface="DejaVu Sans"/>
-                <a:ea typeface="DejaVu Sans"/>
-                <a:cs typeface="DejaVu Sans"/>
+                  <a:srgbClr val="262321"/>
+                </a:solidFill>
+                <a:latin typeface="Liberation Sans"/>
+                <a:ea typeface="Liberation Sans"/>
+                <a:cs typeface="Liberation Sans"/>
               </a:defRPr>
             </a:pPr>
             <a:r>
               <a:rPr sz="2700" b="0">
                 <a:solidFill>
-                  <a:srgbClr val="192D3D"/>
-                </a:solidFill>
-                <a:latin typeface="DejaVu Sans"/>
-                <a:ea typeface="DejaVu Sans"/>
-                <a:cs typeface="DejaVu Sans"/>
+                  <a:srgbClr val="262321"/>
+                </a:solidFill>
+                <a:latin typeface="Liberation Sans"/>
+                <a:ea typeface="Liberation Sans"/>
+                <a:cs typeface="Liberation Sans"/>
               </a:rPr>
               <a:t>Earlier B0 held-out test: 14/30 recovered</a:t>
             </a:r>
@@ -3760,21 +3760,21 @@
             <a:pPr>
               <a:defRPr sz="2700" b="0">
                 <a:solidFill>
-                  <a:srgbClr val="192D3D"/>
-                </a:solidFill>
-                <a:latin typeface="DejaVu Sans"/>
-                <a:ea typeface="DejaVu Sans"/>
-                <a:cs typeface="DejaVu Sans"/>
+                  <a:srgbClr val="262321"/>
+                </a:solidFill>
+                <a:latin typeface="Liberation Sans"/>
+                <a:ea typeface="Liberation Sans"/>
+                <a:cs typeface="Liberation Sans"/>
               </a:defRPr>
             </a:pPr>
             <a:r>
               <a:rPr sz="2700" b="0">
                 <a:solidFill>
-                  <a:srgbClr val="192D3D"/>
-                </a:solidFill>
-                <a:latin typeface="DejaVu Sans"/>
-                <a:ea typeface="DejaVu Sans"/>
-                <a:cs typeface="DejaVu Sans"/>
+                  <a:srgbClr val="262321"/>
+                </a:solidFill>
+                <a:latin typeface="Liberation Sans"/>
+                <a:ea typeface="Liberation Sans"/>
+                <a:cs typeface="Liberation Sans"/>
               </a:rPr>
               <a:t>Median negative-prediction fraction: 35.424%</a:t>
             </a:r>
@@ -3783,21 +3783,21 @@
             <a:pPr>
               <a:defRPr sz="2700" b="0">
                 <a:solidFill>
-                  <a:srgbClr val="192D3D"/>
-                </a:solidFill>
-                <a:latin typeface="DejaVu Sans"/>
-                <a:ea typeface="DejaVu Sans"/>
-                <a:cs typeface="DejaVu Sans"/>
+                  <a:srgbClr val="262321"/>
+                </a:solidFill>
+                <a:latin typeface="Liberation Sans"/>
+                <a:ea typeface="Liberation Sans"/>
+                <a:cs typeface="Liberation Sans"/>
               </a:defRPr>
             </a:pPr>
             <a:r>
               <a:rPr sz="2700" b="0">
                 <a:solidFill>
-                  <a:srgbClr val="192D3D"/>
-                </a:solidFill>
-                <a:latin typeface="DejaVu Sans"/>
-                <a:ea typeface="DejaVu Sans"/>
-                <a:cs typeface="DejaVu Sans"/>
+                  <a:srgbClr val="262321"/>
+                </a:solidFill>
+                <a:latin typeface="Liberation Sans"/>
+                <a:ea typeface="Liberation Sans"/>
+                <a:cs typeface="Liberation Sans"/>
               </a:rPr>
               <a:t>Hard constraints removed physical violations, but strength bias remained.</a:t>
             </a:r>
@@ -3809,7 +3809,7 @@
           <p:cNvPr id="3" name="">
             <a:extLst xmlns:a="http://schemas.openxmlformats.org/drawingml/2006/main">
               <a:ext uri="{FF2B5EF4-FFF2-40B4-BE49-F238E27FC236}">
-                <a16:creationId xmlns:a16="http://schemas.microsoft.com/office/drawing/2014/main" id="{C924F6F0-87F9-4707-AD3D-8FC2857259BC}"/>
+                <a16:creationId xmlns:a16="http://schemas.microsoft.com/office/drawing/2014/main" id="{83ACC751-B3D0-4CF6-97F9-3A09408A2E1D}"/>
               </a:ext>
             </a:extLst>
           </p:cNvPr>
@@ -3840,21 +3840,21 @@
             <a:pPr>
               <a:defRPr sz="1800" b="0">
                 <a:solidFill>
-                  <a:srgbClr val="16688A"/>
-                </a:solidFill>
-                <a:latin typeface="DejaVu Sans"/>
-                <a:ea typeface="DejaVu Sans"/>
-                <a:cs typeface="DejaVu Sans"/>
+                  <a:srgbClr val="713E48"/>
+                </a:solidFill>
+                <a:latin typeface="Liberation Sans"/>
+                <a:ea typeface="Liberation Sans"/>
+                <a:cs typeface="Liberation Sans"/>
               </a:defRPr>
             </a:pPr>
             <a:r>
               <a:rPr sz="1800" b="0">
                 <a:solidFill>
-                  <a:srgbClr val="16688A"/>
-                </a:solidFill>
-                <a:latin typeface="DejaVu Sans"/>
-                <a:ea typeface="DejaVu Sans"/>
-                <a:cs typeface="DejaVu Sans"/>
+                  <a:srgbClr val="713E48"/>
+                </a:solidFill>
+                <a:latin typeface="Liberation Sans"/>
+                <a:ea typeface="Liberation Sans"/>
+                <a:cs typeface="Liberation Sans"/>
               </a:rPr>
               <a:t>Historical B0 median negativity: 35.424%.</a:t>
             </a:r>
@@ -3866,7 +3866,7 @@
           <p:cNvPr id="4" name="">
             <a:extLst xmlns:a="http://schemas.openxmlformats.org/drawingml/2006/main">
               <a:ext uri="{FF2B5EF4-FFF2-40B4-BE49-F238E27FC236}">
-                <a16:creationId xmlns:a16="http://schemas.microsoft.com/office/drawing/2014/main" id="{CEE0CCAB-9DB0-4768-A714-0B6BFECB8CD9}"/>
+                <a16:creationId xmlns:a16="http://schemas.microsoft.com/office/drawing/2014/main" id="{FECDE09F-AF9F-4281-AD6E-4253386C95FA}"/>
               </a:ext>
             </a:extLst>
           </p:cNvPr>
@@ -3897,21 +3897,21 @@
             <a:pPr>
               <a:defRPr sz="1275" b="0">
                 <a:solidFill>
-                  <a:srgbClr val="61717B"/>
-                </a:solidFill>
-                <a:latin typeface="DejaVu Sans"/>
-                <a:ea typeface="DejaVu Sans"/>
-                <a:cs typeface="DejaVu Sans"/>
+                  <a:srgbClr val="716A65"/>
+                </a:solidFill>
+                <a:latin typeface="Liberation Sans"/>
+                <a:ea typeface="Liberation Sans"/>
+                <a:cs typeface="Liberation Sans"/>
               </a:defRPr>
             </a:pPr>
             <a:r>
               <a:rPr sz="1275" b="0">
                 <a:solidFill>
-                  <a:srgbClr val="61717B"/>
-                </a:solidFill>
-                <a:latin typeface="DejaVu Sans"/>
-                <a:ea typeface="DejaVu Sans"/>
-                <a:cs typeface="DejaVu Sans"/>
+                  <a:srgbClr val="716A65"/>
+                </a:solidFill>
+                <a:latin typeface="Liberation Sans"/>
+                <a:ea typeface="Liberation Sans"/>
+                <a:cs typeface="Liberation Sans"/>
               </a:rPr>
               <a:t>6</a:t>
             </a:r>
@@ -3921,7 +3921,7 @@
     </p:spTree>
     <p:extLst>
       <p:ext uri="{BB962C8B-B14F-4D97-AF65-F5344CB8AC3E}">
-        <p14:creationId xmlns:p14="http://schemas.microsoft.com/office/powerpoint/2010/main" val="1395765331"/>
+        <p14:creationId xmlns:p14="http://schemas.microsoft.com/office/powerpoint/2010/main" val="1609950669"/>
       </p:ext>
     </p:extLst>
   </p:cSld>
@@ -3952,7 +3952,7 @@
           <p:cNvPr id="5" name="">
             <a:extLst xmlns:a="http://schemas.openxmlformats.org/drawingml/2006/main">
               <a:ext uri="{FF2B5EF4-FFF2-40B4-BE49-F238E27FC236}">
-                <a16:creationId xmlns:a16="http://schemas.microsoft.com/office/drawing/2014/main" id="{04F422F5-E58D-4351-8D64-77BF9C56E4DE}"/>
+                <a16:creationId xmlns:a16="http://schemas.microsoft.com/office/drawing/2014/main" id="{71AB87CF-C2F3-4554-BB76-F53A65A13E83}"/>
               </a:ext>
             </a:extLst>
           </p:cNvPr>
@@ -3983,21 +3983,21 @@
             <a:pPr>
               <a:defRPr sz="3300" b="1">
                 <a:solidFill>
-                  <a:srgbClr val="192D3D"/>
-                </a:solidFill>
-                <a:latin typeface="DejaVu Sans"/>
-                <a:ea typeface="DejaVu Sans"/>
-                <a:cs typeface="DejaVu Sans"/>
+                  <a:srgbClr val="262321"/>
+                </a:solidFill>
+                <a:latin typeface="Liberation Serif"/>
+                <a:ea typeface="Liberation Serif"/>
+                <a:cs typeface="Liberation Serif"/>
               </a:defRPr>
             </a:pPr>
             <a:r>
               <a:rPr sz="3300" b="1">
                 <a:solidFill>
-                  <a:srgbClr val="192D3D"/>
-                </a:solidFill>
-                <a:latin typeface="DejaVu Sans"/>
-                <a:ea typeface="DejaVu Sans"/>
-                <a:cs typeface="DejaVu Sans"/>
+                  <a:srgbClr val="262321"/>
+                </a:solidFill>
+                <a:latin typeface="Liberation Serif"/>
+                <a:ea typeface="Liberation Serif"/>
+                <a:cs typeface="Liberation Serif"/>
               </a:rPr>
               <a:t>Classical inversion exposed the recovery gap</a:t>
             </a:r>
@@ -4009,7 +4009,7 @@
           <p:cNvPr id="2" name="">
             <a:extLst xmlns:a="http://schemas.openxmlformats.org/drawingml/2006/main">
               <a:ext uri="{FF2B5EF4-FFF2-40B4-BE49-F238E27FC236}">
-                <a16:creationId xmlns:a16="http://schemas.microsoft.com/office/drawing/2014/main" id="{DF41F8D4-F3E1-4B11-AFC5-7B0309FD439D}"/>
+                <a16:creationId xmlns:a16="http://schemas.microsoft.com/office/drawing/2014/main" id="{D4DABAAA-488A-4140-846E-243F3BCBEF80}"/>
               </a:ext>
             </a:extLst>
           </p:cNvPr>
@@ -4040,21 +4040,21 @@
             <a:pPr>
               <a:defRPr sz="2175" b="0">
                 <a:solidFill>
-                  <a:srgbClr val="192D3D"/>
-                </a:solidFill>
-                <a:latin typeface="DejaVu Sans"/>
-                <a:ea typeface="DejaVu Sans"/>
-                <a:cs typeface="DejaVu Sans"/>
+                  <a:srgbClr val="262321"/>
+                </a:solidFill>
+                <a:latin typeface="Liberation Sans"/>
+                <a:ea typeface="Liberation Sans"/>
+                <a:cs typeface="Liberation Sans"/>
               </a:defRPr>
             </a:pPr>
             <a:r>
               <a:rPr sz="2175" b="0">
                 <a:solidFill>
-                  <a:srgbClr val="192D3D"/>
-                </a:solidFill>
-                <a:latin typeface="DejaVu Sans"/>
-                <a:ea typeface="DejaVu Sans"/>
-                <a:cs typeface="DejaVu Sans"/>
+                  <a:srgbClr val="262321"/>
+                </a:solidFill>
+                <a:latin typeface="Liberation Sans"/>
+                <a:ea typeface="Liberation Sans"/>
+                <a:cs typeface="Liberation Sans"/>
               </a:rPr>
               <a:t>Classical inversion recovered 30/30 final cases on identical observations.</a:t>
             </a:r>
@@ -4063,21 +4063,21 @@
             <a:pPr>
               <a:defRPr sz="2175" b="0">
                 <a:solidFill>
-                  <a:srgbClr val="192D3D"/>
-                </a:solidFill>
-                <a:latin typeface="DejaVu Sans"/>
-                <a:ea typeface="DejaVu Sans"/>
-                <a:cs typeface="DejaVu Sans"/>
+                  <a:srgbClr val="262321"/>
+                </a:solidFill>
+                <a:latin typeface="Liberation Sans"/>
+                <a:ea typeface="Liberation Sans"/>
+                <a:cs typeface="Liberation Sans"/>
               </a:defRPr>
             </a:pPr>
             <a:r>
               <a:rPr sz="2175" b="0">
                 <a:solidFill>
-                  <a:srgbClr val="192D3D"/>
-                </a:solidFill>
-                <a:latin typeface="DejaVu Sans"/>
-                <a:ea typeface="DejaVu Sans"/>
-                <a:cs typeface="DejaVu Sans"/>
+                  <a:srgbClr val="262321"/>
+                </a:solidFill>
+                <a:latin typeface="Liberation Sans"/>
+                <a:ea typeface="Liberation Sans"/>
+                <a:cs typeface="Liberation Sans"/>
               </a:rPr>
               <a:t>The tested observations supported better recovery than the PINN achieved.</a:t>
             </a:r>
@@ -4093,7 +4093,7 @@
           <p:nvPr/>
         </p:nvPicPr>
         <p:blipFill>
-          <a:blip xmlns:r="http://schemas.openxmlformats.org/officeDocument/2006/relationships" xmlns:a="http://schemas.openxmlformats.org/drawingml/2006/main" r:embed="R41dff6a0d76e4482"/>
+          <a:blip xmlns:r="http://schemas.openxmlformats.org/officeDocument/2006/relationships" xmlns:a="http://schemas.openxmlformats.org/drawingml/2006/main" r:embed="R689b94cef6e64074"/>
           <a:stretch xmlns:a="http://schemas.openxmlformats.org/drawingml/2006/main"/>
         </p:blipFill>
         <p:spPr>
@@ -4111,7 +4111,7 @@
           <p:cNvPr id="4" name="">
             <a:extLst xmlns:a="http://schemas.openxmlformats.org/drawingml/2006/main">
               <a:ext uri="{FF2B5EF4-FFF2-40B4-BE49-F238E27FC236}">
-                <a16:creationId xmlns:a16="http://schemas.microsoft.com/office/drawing/2014/main" id="{79FD50D3-74DF-4860-A616-11AF32F60710}"/>
+                <a16:creationId xmlns:a16="http://schemas.microsoft.com/office/drawing/2014/main" id="{549A4DBE-2EBF-4422-9E12-90256490718D}"/>
               </a:ext>
             </a:extLst>
           </p:cNvPr>
@@ -4142,21 +4142,21 @@
             <a:pPr>
               <a:defRPr sz="1275" b="0">
                 <a:solidFill>
-                  <a:srgbClr val="61717B"/>
-                </a:solidFill>
-                <a:latin typeface="DejaVu Sans"/>
-                <a:ea typeface="DejaVu Sans"/>
-                <a:cs typeface="DejaVu Sans"/>
+                  <a:srgbClr val="716A65"/>
+                </a:solidFill>
+                <a:latin typeface="Liberation Sans"/>
+                <a:ea typeface="Liberation Sans"/>
+                <a:cs typeface="Liberation Sans"/>
               </a:defRPr>
             </a:pPr>
             <a:r>
               <a:rPr sz="1275" b="0">
                 <a:solidFill>
-                  <a:srgbClr val="61717B"/>
-                </a:solidFill>
-                <a:latin typeface="DejaVu Sans"/>
-                <a:ea typeface="DejaVu Sans"/>
-                <a:cs typeface="DejaVu Sans"/>
+                  <a:srgbClr val="716A65"/>
+                </a:solidFill>
+                <a:latin typeface="Liberation Sans"/>
+                <a:ea typeface="Liberation Sans"/>
+                <a:cs typeface="Liberation Sans"/>
               </a:rPr>
               <a:t>7</a:t>
             </a:r>
@@ -4166,7 +4166,7 @@
     </p:spTree>
     <p:extLst>
       <p:ext uri="{BB962C8B-B14F-4D97-AF65-F5344CB8AC3E}">
-        <p14:creationId xmlns:p14="http://schemas.microsoft.com/office/powerpoint/2010/main" val="1733282778"/>
+        <p14:creationId xmlns:p14="http://schemas.microsoft.com/office/powerpoint/2010/main" val="1091428396"/>
       </p:ext>
     </p:extLst>
   </p:cSld>
@@ -4197,7 +4197,7 @@
           <p:cNvPr id="5" name="">
             <a:extLst xmlns:a="http://schemas.openxmlformats.org/drawingml/2006/main">
               <a:ext uri="{FF2B5EF4-FFF2-40B4-BE49-F238E27FC236}">
-                <a16:creationId xmlns:a16="http://schemas.microsoft.com/office/drawing/2014/main" id="{07718AC1-D039-416A-8DE7-2F7ACA5C3B99}"/>
+                <a16:creationId xmlns:a16="http://schemas.microsoft.com/office/drawing/2014/main" id="{3E64CD1B-789E-4108-BAF6-F8C498102EC5}"/>
               </a:ext>
             </a:extLst>
           </p:cNvPr>
@@ -4228,21 +4228,21 @@
             <a:pPr>
               <a:defRPr sz="3300" b="1">
                 <a:solidFill>
-                  <a:srgbClr val="192D3D"/>
-                </a:solidFill>
-                <a:latin typeface="DejaVu Sans"/>
-                <a:ea typeface="DejaVu Sans"/>
-                <a:cs typeface="DejaVu Sans"/>
+                  <a:srgbClr val="262321"/>
+                </a:solidFill>
+                <a:latin typeface="Liberation Serif"/>
+                <a:ea typeface="Liberation Serif"/>
+                <a:cs typeface="Liberation Serif"/>
               </a:defRPr>
             </a:pPr>
             <a:r>
               <a:rPr sz="3300" b="1">
                 <a:solidFill>
-                  <a:srgbClr val="192D3D"/>
-                </a:solidFill>
-                <a:latin typeface="DejaVu Sans"/>
-                <a:ea typeface="DejaVu Sans"/>
-                <a:cs typeface="DejaVu Sans"/>
+                  <a:srgbClr val="262321"/>
+                </a:solidFill>
+                <a:latin typeface="Liberation Serif"/>
+                <a:ea typeface="Liberation Serif"/>
+                <a:cs typeface="Liberation Serif"/>
               </a:rPr>
               <a:t>J1 profiles source amplitude analytically</a:t>
             </a:r>
@@ -4254,7 +4254,7 @@
           <p:cNvPr id="2" name="">
             <a:extLst xmlns:a="http://schemas.openxmlformats.org/drawingml/2006/main">
               <a:ext uri="{FF2B5EF4-FFF2-40B4-BE49-F238E27FC236}">
-                <a16:creationId xmlns:a16="http://schemas.microsoft.com/office/drawing/2014/main" id="{B64D14E0-C0F6-4DDD-9C9A-827CFF9F9410}"/>
+                <a16:creationId xmlns:a16="http://schemas.microsoft.com/office/drawing/2014/main" id="{B4E8DB60-105F-439F-AD34-105D3F5E90C3}"/>
               </a:ext>
             </a:extLst>
           </p:cNvPr>
@@ -4285,21 +4285,21 @@
             <a:pPr>
               <a:defRPr sz="2400" b="0">
                 <a:solidFill>
-                  <a:srgbClr val="192D3D"/>
-                </a:solidFill>
-                <a:latin typeface="DejaVu Sans"/>
-                <a:ea typeface="DejaVu Sans"/>
-                <a:cs typeface="DejaVu Sans"/>
+                  <a:srgbClr val="262321"/>
+                </a:solidFill>
+                <a:latin typeface="Liberation Sans"/>
+                <a:ea typeface="Liberation Sans"/>
+                <a:cs typeface="Liberation Sans"/>
               </a:defRPr>
             </a:pPr>
             <a:r>
               <a:rPr sz="2400" b="0">
                 <a:solidFill>
-                  <a:srgbClr val="192D3D"/>
-                </a:solidFill>
-                <a:latin typeface="DejaVu Sans"/>
-                <a:ea typeface="DejaVu Sans"/>
-                <a:cs typeface="DejaVu Sans"/>
+                  <a:srgbClr val="262321"/>
+                </a:solidFill>
+                <a:latin typeface="Liberation Sans"/>
+                <a:ea typeface="Liberation Sans"/>
+                <a:cs typeface="Liberation Sans"/>
               </a:rPr>
               <a:t>Residual: R0 - QG</a:t>
             </a:r>
@@ -4308,21 +4308,21 @@
             <a:pPr>
               <a:defRPr sz="2400" b="0">
                 <a:solidFill>
-                  <a:srgbClr val="192D3D"/>
-                </a:solidFill>
-                <a:latin typeface="DejaVu Sans"/>
-                <a:ea typeface="DejaVu Sans"/>
-                <a:cs typeface="DejaVu Sans"/>
+                  <a:srgbClr val="262321"/>
+                </a:solidFill>
+                <a:latin typeface="Liberation Sans"/>
+                <a:ea typeface="Liberation Sans"/>
+                <a:cs typeface="Liberation Sans"/>
               </a:defRPr>
             </a:pPr>
             <a:r>
               <a:rPr sz="2400" b="0">
                 <a:solidFill>
-                  <a:srgbClr val="192D3D"/>
-                </a:solidFill>
-                <a:latin typeface="DejaVu Sans"/>
-                <a:ea typeface="DejaVu Sans"/>
-                <a:cs typeface="DejaVu Sans"/>
+                  <a:srgbClr val="262321"/>
+                </a:solidFill>
+                <a:latin typeface="Liberation Sans"/>
+                <a:ea typeface="Liberation Sans"/>
+                <a:cs typeface="Liberation Sans"/>
               </a:rPr>
               <a:t>Q* = sum(w_i G_i R0_i) / sum(w_i G_i²)</a:t>
             </a:r>
@@ -4336,21 +4336,21 @@
             <a:pPr>
               <a:defRPr sz="2400" b="0">
                 <a:solidFill>
-                  <a:srgbClr val="192D3D"/>
-                </a:solidFill>
-                <a:latin typeface="DejaVu Sans"/>
-                <a:ea typeface="DejaVu Sans"/>
-                <a:cs typeface="DejaVu Sans"/>
+                  <a:srgbClr val="262321"/>
+                </a:solidFill>
+                <a:latin typeface="Liberation Sans"/>
+                <a:ea typeface="Liberation Sans"/>
+                <a:cs typeface="Liberation Sans"/>
               </a:defRPr>
             </a:pPr>
             <a:r>
               <a:rPr sz="2400" b="0">
                 <a:solidFill>
-                  <a:srgbClr val="192D3D"/>
-                </a:solidFill>
-                <a:latin typeface="DejaVu Sans"/>
-                <a:ea typeface="DejaVu Sans"/>
-                <a:cs typeface="DejaVu Sans"/>
+                  <a:srgbClr val="262321"/>
+                </a:solidFill>
+                <a:latin typeface="Liberation Sans"/>
+                <a:ea typeface="Liberation Sans"/>
+                <a:cs typeface="Liberation Sans"/>
               </a:rPr>
               <a:t>Q leaves Adam's parameter list. The field and location remain trainable.</a:t>
             </a:r>
@@ -4359,21 +4359,21 @@
             <a:pPr>
               <a:defRPr sz="2400" b="0">
                 <a:solidFill>
-                  <a:srgbClr val="192D3D"/>
-                </a:solidFill>
-                <a:latin typeface="DejaVu Sans"/>
-                <a:ea typeface="DejaVu Sans"/>
-                <a:cs typeface="DejaVu Sans"/>
+                  <a:srgbClr val="262321"/>
+                </a:solidFill>
+                <a:latin typeface="Liberation Sans"/>
+                <a:ea typeface="Liberation Sans"/>
+                <a:cs typeface="Liberation Sans"/>
               </a:defRPr>
             </a:pPr>
             <a:r>
               <a:rPr sz="2400" b="0">
                 <a:solidFill>
-                  <a:srgbClr val="192D3D"/>
-                </a:solidFill>
-                <a:latin typeface="DejaVu Sans"/>
-                <a:ea typeface="DejaVu Sans"/>
-                <a:cs typeface="DejaVu Sans"/>
+                  <a:srgbClr val="262321"/>
+                </a:solidFill>
+                <a:latin typeface="Liberation Sans"/>
+                <a:ea typeface="Liberation Sans"/>
+                <a:cs typeface="Liberation Sans"/>
               </a:rPr>
               <a:t>This minimizes the sampled PDE objective, not observation mismatch through a solver.</a:t>
             </a:r>
@@ -4385,7 +4385,7 @@
           <p:cNvPr id="3" name="">
             <a:extLst xmlns:a="http://schemas.openxmlformats.org/drawingml/2006/main">
               <a:ext uri="{FF2B5EF4-FFF2-40B4-BE49-F238E27FC236}">
-                <a16:creationId xmlns:a16="http://schemas.microsoft.com/office/drawing/2014/main" id="{6B52C5D2-4102-4D6B-8263-FC991479E2F8}"/>
+                <a16:creationId xmlns:a16="http://schemas.microsoft.com/office/drawing/2014/main" id="{480490C8-1D6A-4219-BBAB-2ECA82690ABB}"/>
               </a:ext>
             </a:extLst>
           </p:cNvPr>
@@ -4416,21 +4416,21 @@
             <a:pPr>
               <a:defRPr sz="1725" b="0">
                 <a:solidFill>
-                  <a:srgbClr val="16688A"/>
-                </a:solidFill>
-                <a:latin typeface="DejaVu Sans"/>
-                <a:ea typeface="DejaVu Sans"/>
-                <a:cs typeface="DejaVu Sans"/>
+                  <a:srgbClr val="713E48"/>
+                </a:solidFill>
+                <a:latin typeface="Liberation Sans"/>
+                <a:ea typeface="Liberation Sans"/>
+                <a:cs typeface="Liberation Sans"/>
               </a:defRPr>
             </a:pPr>
             <a:r>
               <a:rPr sz="1725" b="0">
                 <a:solidFill>
-                  <a:srgbClr val="16688A"/>
-                </a:solidFill>
-                <a:latin typeface="DejaVu Sans"/>
-                <a:ea typeface="DejaVu Sans"/>
-                <a:cs typeface="DejaVu Sans"/>
+                  <a:srgbClr val="713E48"/>
+                </a:solidFill>
+                <a:latin typeface="Liberation Sans"/>
+                <a:ea typeface="Liberation Sans"/>
+                <a:cs typeface="Liberation Sans"/>
               </a:rPr>
               <a:t>Q is profiled each update, plus a fixed terminal profile.</a:t>
             </a:r>
@@ -4442,7 +4442,7 @@
           <p:cNvPr id="4" name="">
             <a:extLst xmlns:a="http://schemas.openxmlformats.org/drawingml/2006/main">
               <a:ext uri="{FF2B5EF4-FFF2-40B4-BE49-F238E27FC236}">
-                <a16:creationId xmlns:a16="http://schemas.microsoft.com/office/drawing/2014/main" id="{F44F9107-6122-4763-942B-E410A32F8E0B}"/>
+                <a16:creationId xmlns:a16="http://schemas.microsoft.com/office/drawing/2014/main" id="{3E29BE24-6A2C-4D17-B52B-CFC9973B5C5B}"/>
               </a:ext>
             </a:extLst>
           </p:cNvPr>
@@ -4473,21 +4473,21 @@
             <a:pPr>
               <a:defRPr sz="1275" b="0">
                 <a:solidFill>
-                  <a:srgbClr val="61717B"/>
-                </a:solidFill>
-                <a:latin typeface="DejaVu Sans"/>
-                <a:ea typeface="DejaVu Sans"/>
-                <a:cs typeface="DejaVu Sans"/>
+                  <a:srgbClr val="716A65"/>
+                </a:solidFill>
+                <a:latin typeface="Liberation Sans"/>
+                <a:ea typeface="Liberation Sans"/>
+                <a:cs typeface="Liberation Sans"/>
               </a:defRPr>
             </a:pPr>
             <a:r>
               <a:rPr sz="1275" b="0">
                 <a:solidFill>
-                  <a:srgbClr val="61717B"/>
-                </a:solidFill>
-                <a:latin typeface="DejaVu Sans"/>
-                <a:ea typeface="DejaVu Sans"/>
-                <a:cs typeface="DejaVu Sans"/>
+                  <a:srgbClr val="716A65"/>
+                </a:solidFill>
+                <a:latin typeface="Liberation Sans"/>
+                <a:ea typeface="Liberation Sans"/>
+                <a:cs typeface="Liberation Sans"/>
               </a:rPr>
               <a:t>8</a:t>
             </a:r>
@@ -4497,7 +4497,7 @@
     </p:spTree>
     <p:extLst>
       <p:ext uri="{BB962C8B-B14F-4D97-AF65-F5344CB8AC3E}">
-        <p14:creationId xmlns:p14="http://schemas.microsoft.com/office/powerpoint/2010/main" val="1920148363"/>
+        <p14:creationId xmlns:p14="http://schemas.microsoft.com/office/powerpoint/2010/main" val="399169042"/>
       </p:ext>
     </p:extLst>
   </p:cSld>
@@ -4528,7 +4528,7 @@
           <p:cNvPr id="7" name="">
             <a:extLst xmlns:a="http://schemas.openxmlformats.org/drawingml/2006/main">
               <a:ext uri="{FF2B5EF4-FFF2-40B4-BE49-F238E27FC236}">
-                <a16:creationId xmlns:a16="http://schemas.microsoft.com/office/drawing/2014/main" id="{67A3EE9C-8147-4864-A73F-68D20D60FA93}"/>
+                <a16:creationId xmlns:a16="http://schemas.microsoft.com/office/drawing/2014/main" id="{4913AB12-70C6-484B-98C3-79BA1F237645}"/>
               </a:ext>
             </a:extLst>
           </p:cNvPr>
@@ -4559,21 +4559,21 @@
             <a:pPr>
               <a:defRPr sz="3300" b="1">
                 <a:solidFill>
-                  <a:srgbClr val="192D3D"/>
-                </a:solidFill>
-                <a:latin typeface="DejaVu Sans"/>
-                <a:ea typeface="DejaVu Sans"/>
-                <a:cs typeface="DejaVu Sans"/>
+                  <a:srgbClr val="262321"/>
+                </a:solidFill>
+                <a:latin typeface="Liberation Serif"/>
+                <a:ea typeface="Liberation Serif"/>
+                <a:cs typeface="Liberation Serif"/>
               </a:defRPr>
             </a:pPr>
             <a:r>
               <a:rPr sz="3300" b="1">
                 <a:solidFill>
-                  <a:srgbClr val="192D3D"/>
-                </a:solidFill>
-                <a:latin typeface="DejaVu Sans"/>
-                <a:ea typeface="DejaVu Sans"/>
-                <a:cs typeface="DejaVu Sans"/>
+                  <a:srgbClr val="262321"/>
+                </a:solidFill>
+                <a:latin typeface="Liberation Serif"/>
+                <a:ea typeface="Liberation Serif"/>
+                <a:cs typeface="Liberation Serif"/>
               </a:rPr>
               <a:t>J1 failed final confirmation</a:t>
             </a:r>
@@ -4585,7 +4585,7 @@
           <p:cNvPr id="2" name="">
             <a:extLst xmlns:a="http://schemas.openxmlformats.org/drawingml/2006/main">
               <a:ext uri="{FF2B5EF4-FFF2-40B4-BE49-F238E27FC236}">
-                <a16:creationId xmlns:a16="http://schemas.microsoft.com/office/drawing/2014/main" id="{35519AC7-AFF8-4FC2-BA5D-79D16C8758B9}"/>
+                <a16:creationId xmlns:a16="http://schemas.microsoft.com/office/drawing/2014/main" id="{2D6108A2-C0BE-49B1-8BCC-8B5875204552}"/>
               </a:ext>
             </a:extLst>
           </p:cNvPr>
@@ -4616,21 +4616,21 @@
             <a:pPr>
               <a:defRPr sz="2550" b="1">
                 <a:solidFill>
-                  <a:srgbClr val="A63F26"/>
-                </a:solidFill>
-                <a:latin typeface="DejaVu Sans"/>
-                <a:ea typeface="DejaVu Sans"/>
-                <a:cs typeface="DejaVu Sans"/>
+                  <a:srgbClr val="8C302F"/>
+                </a:solidFill>
+                <a:latin typeface="Liberation Serif"/>
+                <a:ea typeface="Liberation Serif"/>
+                <a:cs typeface="Liberation Serif"/>
               </a:defRPr>
             </a:pPr>
             <a:r>
               <a:rPr sz="2550" b="1">
                 <a:solidFill>
-                  <a:srgbClr val="A63F26"/>
-                </a:solidFill>
-                <a:latin typeface="DejaVu Sans"/>
-                <a:ea typeface="DejaVu Sans"/>
-                <a:cs typeface="DejaVu Sans"/>
+                  <a:srgbClr val="8C302F"/>
+                </a:solidFill>
+                <a:latin typeface="Liberation Serif"/>
+                <a:ea typeface="Liberation Serif"/>
+                <a:cs typeface="Liberation Serif"/>
               </a:rPr>
               <a:t>23/30 = 76.67%; required 27/30 = 90%</a:t>
             </a:r>
@@ -4639,21 +4639,21 @@
             <a:pPr>
               <a:defRPr sz="2550" b="1">
                 <a:solidFill>
-                  <a:srgbClr val="A63F26"/>
-                </a:solidFill>
-                <a:latin typeface="DejaVu Sans"/>
-                <a:ea typeface="DejaVu Sans"/>
-                <a:cs typeface="DejaVu Sans"/>
+                  <a:srgbClr val="8C302F"/>
+                </a:solidFill>
+                <a:latin typeface="Liberation Serif"/>
+                <a:ea typeface="Liberation Serif"/>
+                <a:cs typeface="Liberation Serif"/>
               </a:defRPr>
             </a:pPr>
             <a:r>
               <a:rPr sz="2550" b="1">
                 <a:solidFill>
-                  <a:srgbClr val="A63F26"/>
-                </a:solidFill>
-                <a:latin typeface="DejaVu Sans"/>
-                <a:ea typeface="DejaVu Sans"/>
-                <a:cs typeface="DejaVu Sans"/>
+                  <a:srgbClr val="8C302F"/>
+                </a:solidFill>
+                <a:latin typeface="Liberation Serif"/>
+                <a:ea typeface="Liberation Serif"/>
+                <a:cs typeface="Liberation Serif"/>
               </a:rPr>
               <a:t>28 Q underestimates / 2 overestimates</a:t>
             </a:r>
@@ -4665,7 +4665,7 @@
           <p:cNvPr id="3" name="">
             <a:extLst xmlns:a="http://schemas.openxmlformats.org/drawingml/2006/main">
               <a:ext uri="{FF2B5EF4-FFF2-40B4-BE49-F238E27FC236}">
-                <a16:creationId xmlns:a16="http://schemas.microsoft.com/office/drawing/2014/main" id="{7E0D54FC-B2C8-4B65-BC17-E578B1E17B97}"/>
+                <a16:creationId xmlns:a16="http://schemas.microsoft.com/office/drawing/2014/main" id="{7C196430-630C-4399-A48D-4C305354B9AE}"/>
               </a:ext>
             </a:extLst>
           </p:cNvPr>
@@ -4696,21 +4696,21 @@
             <a:pPr>
               <a:defRPr sz="1500" b="0">
                 <a:solidFill>
-                  <a:srgbClr val="192D3D"/>
-                </a:solidFill>
-                <a:latin typeface="DejaVu Sans"/>
-                <a:ea typeface="DejaVu Sans"/>
-                <a:cs typeface="DejaVu Sans"/>
+                  <a:srgbClr val="262321"/>
+                </a:solidFill>
+                <a:latin typeface="Liberation Sans"/>
+                <a:ea typeface="Liberation Sans"/>
+                <a:cs typeface="Liberation Sans"/>
               </a:defRPr>
             </a:pPr>
             <a:r>
               <a:rPr sz="1500" b="0">
                 <a:solidFill>
-                  <a:srgbClr val="192D3D"/>
-                </a:solidFill>
-                <a:latin typeface="DejaVu Sans"/>
-                <a:ea typeface="DejaVu Sans"/>
-                <a:cs typeface="DejaVu Sans"/>
+                  <a:srgbClr val="262321"/>
+                </a:solidFill>
+                <a:latin typeface="Liberation Sans"/>
+                <a:ea typeface="Liberation Sans"/>
+                <a:cs typeface="Liberation Sans"/>
               </a:rPr>
               <a:t>Error columns report medians across all 30 fresh scenarios</a:t>
             </a:r>
@@ -4747,11 +4747,11 @@
                       <a:r>
                         <a:rPr sz="1875" b="1">
                           <a:solidFill>
-                            <a:srgbClr val="192D3D"/>
+                            <a:srgbClr val="262321"/>
                           </a:solidFill>
-                          <a:latin typeface="DejaVu Sans"/>
-                          <a:ea typeface="DejaVu Sans"/>
-                          <a:cs typeface="DejaVu Sans"/>
+                          <a:latin typeface="Liberation Sans"/>
+                          <a:ea typeface="Liberation Sans"/>
+                          <a:cs typeface="Liberation Sans"/>
                         </a:rPr>
                         <a:t>Method</a:t>
                       </a:r>
@@ -4759,7 +4759,7 @@
                   </a:txBody>
                   <a:tcPr marL="91440" marR="91440" marT="45720" marB="45720">
                     <a:solidFill>
-                      <a:srgbClr val="E8F0F3"/>
+                      <a:srgbClr val="F2ECE8"/>
                     </a:solidFill>
                   </a:tcPr>
                 </a:tc>
@@ -4771,11 +4771,11 @@
                       <a:r>
                         <a:rPr sz="1875" b="1">
                           <a:solidFill>
-                            <a:srgbClr val="192D3D"/>
+                            <a:srgbClr val="262321"/>
                           </a:solidFill>
-                          <a:latin typeface="DejaVu Sans"/>
-                          <a:ea typeface="DejaVu Sans"/>
-                          <a:cs typeface="DejaVu Sans"/>
+                          <a:latin typeface="Liberation Sans"/>
+                          <a:ea typeface="Liberation Sans"/>
+                          <a:cs typeface="Liberation Sans"/>
                         </a:rPr>
                         <a:t>Recovery</a:t>
                       </a:r>
@@ -4783,7 +4783,7 @@
                   </a:txBody>
                   <a:tcPr marL="91440" marR="91440" marT="45720" marB="45720">
                     <a:solidFill>
-                      <a:srgbClr val="E8F0F3"/>
+                      <a:srgbClr val="F2ECE8"/>
                     </a:solidFill>
                   </a:tcPr>
                 </a:tc>
@@ -4795,11 +4795,11 @@
                       <a:r>
                         <a:rPr sz="1875" b="1">
                           <a:solidFill>
-                            <a:srgbClr val="192D3D"/>
+                            <a:srgbClr val="262321"/>
                           </a:solidFill>
-                          <a:latin typeface="DejaVu Sans"/>
-                          <a:ea typeface="DejaVu Sans"/>
-                          <a:cs typeface="DejaVu Sans"/>
+                          <a:latin typeface="Liberation Sans"/>
+                          <a:ea typeface="Liberation Sans"/>
+                          <a:cs typeface="Liberation Sans"/>
                         </a:rPr>
                         <a:t>Localization</a:t>
                       </a:r>
@@ -4807,7 +4807,7 @@
                   </a:txBody>
                   <a:tcPr marL="91440" marR="91440" marT="45720" marB="45720">
                     <a:solidFill>
-                      <a:srgbClr val="E8F0F3"/>
+                      <a:srgbClr val="F2ECE8"/>
                     </a:solidFill>
                   </a:tcPr>
                 </a:tc>
@@ -4819,11 +4819,11 @@
                       <a:r>
                         <a:rPr sz="1875" b="1">
                           <a:solidFill>
-                            <a:srgbClr val="192D3D"/>
+                            <a:srgbClr val="262321"/>
                           </a:solidFill>
-                          <a:latin typeface="DejaVu Sans"/>
-                          <a:ea typeface="DejaVu Sans"/>
-                          <a:cs typeface="DejaVu Sans"/>
+                          <a:latin typeface="Liberation Sans"/>
+                          <a:ea typeface="Liberation Sans"/>
+                          <a:cs typeface="Liberation Sans"/>
                         </a:rPr>
                         <a:t>Q error</a:t>
                       </a:r>
@@ -4831,7 +4831,7 @@
                   </a:txBody>
                   <a:tcPr marL="91440" marR="91440" marT="45720" marB="45720">
                     <a:solidFill>
-                      <a:srgbClr val="E8F0F3"/>
+                      <a:srgbClr val="F2ECE8"/>
                     </a:solidFill>
                   </a:tcPr>
                 </a:tc>
@@ -4843,11 +4843,11 @@
                       <a:r>
                         <a:rPr sz="1875" b="1">
                           <a:solidFill>
-                            <a:srgbClr val="192D3D"/>
+                            <a:srgbClr val="262321"/>
                           </a:solidFill>
-                          <a:latin typeface="DejaVu Sans"/>
-                          <a:ea typeface="DejaVu Sans"/>
-                          <a:cs typeface="DejaVu Sans"/>
+                          <a:latin typeface="Liberation Sans"/>
+                          <a:ea typeface="Liberation Sans"/>
+                          <a:cs typeface="Liberation Sans"/>
                         </a:rPr>
                         <a:t>Field L2</a:t>
                       </a:r>
@@ -4855,7 +4855,7 @@
                   </a:txBody>
                   <a:tcPr marL="91440" marR="91440" marT="45720" marB="45720">
                     <a:solidFill>
-                      <a:srgbClr val="E8F0F3"/>
+                      <a:srgbClr val="F2ECE8"/>
                     </a:solidFill>
                   </a:tcPr>
                 </a:tc>
@@ -4869,11 +4869,11 @@
                       <a:r>
                         <a:rPr sz="1875" b="0">
                           <a:solidFill>
-                            <a:srgbClr val="192D3D"/>
+                            <a:srgbClr val="262321"/>
                           </a:solidFill>
-                          <a:latin typeface="DejaVu Sans"/>
-                          <a:ea typeface="DejaVu Sans"/>
-                          <a:cs typeface="DejaVu Sans"/>
+                          <a:latin typeface="Liberation Sans"/>
+                          <a:ea typeface="Liberation Sans"/>
+                          <a:cs typeface="Liberation Sans"/>
                         </a:rPr>
                         <a:t>J1 PINN</a:t>
                       </a:r>
@@ -4893,11 +4893,11 @@
                       <a:r>
                         <a:rPr sz="1875" b="0">
                           <a:solidFill>
-                            <a:srgbClr val="192D3D"/>
+                            <a:srgbClr val="262321"/>
                           </a:solidFill>
-                          <a:latin typeface="DejaVu Sans"/>
-                          <a:ea typeface="DejaVu Sans"/>
-                          <a:cs typeface="DejaVu Sans"/>
+                          <a:latin typeface="Liberation Sans"/>
+                          <a:ea typeface="Liberation Sans"/>
+                          <a:cs typeface="Liberation Sans"/>
                         </a:rPr>
                         <a:t>23/30</a:t>
                       </a:r>
@@ -4917,11 +4917,11 @@
                       <a:r>
                         <a:rPr sz="1875" b="0">
                           <a:solidFill>
-                            <a:srgbClr val="192D3D"/>
+                            <a:srgbClr val="262321"/>
                           </a:solidFill>
-                          <a:latin typeface="DejaVu Sans"/>
-                          <a:ea typeface="DejaVu Sans"/>
-                          <a:cs typeface="DejaVu Sans"/>
+                          <a:latin typeface="Liberation Sans"/>
+                          <a:ea typeface="Liberation Sans"/>
+                          <a:cs typeface="Liberation Sans"/>
                         </a:rPr>
                         <a:t>0.005574</a:t>
                       </a:r>
@@ -4941,11 +4941,11 @@
                       <a:r>
                         <a:rPr sz="1875" b="0">
                           <a:solidFill>
-                            <a:srgbClr val="192D3D"/>
+                            <a:srgbClr val="262321"/>
                           </a:solidFill>
-                          <a:latin typeface="DejaVu Sans"/>
-                          <a:ea typeface="DejaVu Sans"/>
-                          <a:cs typeface="DejaVu Sans"/>
+                          <a:latin typeface="Liberation Sans"/>
+                          <a:ea typeface="Liberation Sans"/>
+                          <a:cs typeface="Liberation Sans"/>
                         </a:rPr>
                         <a:t>5.975%</a:t>
                       </a:r>
@@ -4965,11 +4965,11 @@
                       <a:r>
                         <a:rPr sz="1875" b="0">
                           <a:solidFill>
-                            <a:srgbClr val="192D3D"/>
+                            <a:srgbClr val="262321"/>
                           </a:solidFill>
-                          <a:latin typeface="DejaVu Sans"/>
-                          <a:ea typeface="DejaVu Sans"/>
-                          <a:cs typeface="DejaVu Sans"/>
+                          <a:latin typeface="Liberation Sans"/>
+                          <a:ea typeface="Liberation Sans"/>
+                          <a:cs typeface="Liberation Sans"/>
                         </a:rPr>
                         <a:t>7.423%</a:t>
                       </a:r>
@@ -4991,11 +4991,11 @@
                       <a:r>
                         <a:rPr sz="1875" b="0">
                           <a:solidFill>
-                            <a:srgbClr val="192D3D"/>
+                            <a:srgbClr val="262321"/>
                           </a:solidFill>
-                          <a:latin typeface="DejaVu Sans"/>
-                          <a:ea typeface="DejaVu Sans"/>
-                          <a:cs typeface="DejaVu Sans"/>
+                          <a:latin typeface="Liberation Sans"/>
+                          <a:ea typeface="Liberation Sans"/>
+                          <a:cs typeface="Liberation Sans"/>
                         </a:rPr>
                         <a:t>B_revised</a:t>
                       </a:r>
@@ -5015,11 +5015,11 @@
                       <a:r>
                         <a:rPr sz="1875" b="0">
                           <a:solidFill>
-                            <a:srgbClr val="192D3D"/>
+                            <a:srgbClr val="262321"/>
                           </a:solidFill>
-                          <a:latin typeface="DejaVu Sans"/>
-                          <a:ea typeface="DejaVu Sans"/>
-                          <a:cs typeface="DejaVu Sans"/>
+                          <a:latin typeface="Liberation Sans"/>
+                          <a:ea typeface="Liberation Sans"/>
+                          <a:cs typeface="Liberation Sans"/>
                         </a:rPr>
                         <a:t>21/30</a:t>
                       </a:r>
@@ -5039,11 +5039,11 @@
                       <a:r>
                         <a:rPr sz="1875" b="0">
                           <a:solidFill>
-                            <a:srgbClr val="192D3D"/>
+                            <a:srgbClr val="262321"/>
                           </a:solidFill>
-                          <a:latin typeface="DejaVu Sans"/>
-                          <a:ea typeface="DejaVu Sans"/>
-                          <a:cs typeface="DejaVu Sans"/>
+                          <a:latin typeface="Liberation Sans"/>
+                          <a:ea typeface="Liberation Sans"/>
+                          <a:cs typeface="Liberation Sans"/>
                         </a:rPr>
                         <a:t>0.009186</a:t>
                       </a:r>
@@ -5063,11 +5063,11 @@
                       <a:r>
                         <a:rPr sz="1875" b="0">
                           <a:solidFill>
-                            <a:srgbClr val="192D3D"/>
+                            <a:srgbClr val="262321"/>
                           </a:solidFill>
-                          <a:latin typeface="DejaVu Sans"/>
-                          <a:ea typeface="DejaVu Sans"/>
-                          <a:cs typeface="DejaVu Sans"/>
+                          <a:latin typeface="Liberation Sans"/>
+                          <a:ea typeface="Liberation Sans"/>
+                          <a:cs typeface="Liberation Sans"/>
                         </a:rPr>
                         <a:t>9.319%</a:t>
                       </a:r>
@@ -5087,11 +5087,11 @@
                       <a:r>
                         <a:rPr sz="1875" b="0">
                           <a:solidFill>
-                            <a:srgbClr val="192D3D"/>
+                            <a:srgbClr val="262321"/>
                           </a:solidFill>
-                          <a:latin typeface="DejaVu Sans"/>
-                          <a:ea typeface="DejaVu Sans"/>
-                          <a:cs typeface="DejaVu Sans"/>
+                          <a:latin typeface="Liberation Sans"/>
+                          <a:ea typeface="Liberation Sans"/>
+                          <a:cs typeface="Liberation Sans"/>
                         </a:rPr>
                         <a:t>11.048%</a:t>
                       </a:r>
@@ -5113,11 +5113,11 @@
                       <a:r>
                         <a:rPr sz="1875" b="0">
                           <a:solidFill>
-                            <a:srgbClr val="192D3D"/>
+                            <a:srgbClr val="262321"/>
                           </a:solidFill>
-                          <a:latin typeface="DejaVu Sans"/>
-                          <a:ea typeface="DejaVu Sans"/>
-                          <a:cs typeface="DejaVu Sans"/>
+                          <a:latin typeface="Liberation Sans"/>
+                          <a:ea typeface="Liberation Sans"/>
+                          <a:cs typeface="Liberation Sans"/>
                         </a:rPr>
                         <a:t>Classical</a:t>
                       </a:r>
@@ -5137,11 +5137,11 @@
                       <a:r>
                         <a:rPr sz="1875" b="0">
                           <a:solidFill>
-                            <a:srgbClr val="192D3D"/>
+                            <a:srgbClr val="262321"/>
                           </a:solidFill>
-                          <a:latin typeface="DejaVu Sans"/>
-                          <a:ea typeface="DejaVu Sans"/>
-                          <a:cs typeface="DejaVu Sans"/>
+                          <a:latin typeface="Liberation Sans"/>
+                          <a:ea typeface="Liberation Sans"/>
+                          <a:cs typeface="Liberation Sans"/>
                         </a:rPr>
                         <a:t>30/30</a:t>
                       </a:r>
@@ -5161,11 +5161,11 @@
                       <a:r>
                         <a:rPr sz="1875" b="0">
                           <a:solidFill>
-                            <a:srgbClr val="192D3D"/>
+                            <a:srgbClr val="262321"/>
                           </a:solidFill>
-                          <a:latin typeface="DejaVu Sans"/>
-                          <a:ea typeface="DejaVu Sans"/>
-                          <a:cs typeface="DejaVu Sans"/>
+                          <a:latin typeface="Liberation Sans"/>
+                          <a:ea typeface="Liberation Sans"/>
+                          <a:cs typeface="Liberation Sans"/>
                         </a:rPr>
                         <a:t>0.001111</a:t>
                       </a:r>
@@ -5185,11 +5185,11 @@
                       <a:r>
                         <a:rPr sz="1875" b="0">
                           <a:solidFill>
-                            <a:srgbClr val="192D3D"/>
+                            <a:srgbClr val="262321"/>
                           </a:solidFill>
-                          <a:latin typeface="DejaVu Sans"/>
-                          <a:ea typeface="DejaVu Sans"/>
-                          <a:cs typeface="DejaVu Sans"/>
+                          <a:latin typeface="Liberation Sans"/>
+                          <a:ea typeface="Liberation Sans"/>
+                          <a:cs typeface="Liberation Sans"/>
                         </a:rPr>
                         <a:t>1.218%</a:t>
                       </a:r>
@@ -5209,11 +5209,11 @@
                       <a:r>
                         <a:rPr sz="1875" b="0">
                           <a:solidFill>
-                            <a:srgbClr val="192D3D"/>
+                            <a:srgbClr val="262321"/>
                           </a:solidFill>
-                          <a:latin typeface="DejaVu Sans"/>
-                          <a:ea typeface="DejaVu Sans"/>
-                          <a:cs typeface="DejaVu Sans"/>
+                          <a:latin typeface="Liberation Sans"/>
+                          <a:ea typeface="Liberation Sans"/>
+                          <a:cs typeface="Liberation Sans"/>
                         </a:rPr>
                         <a:t>1.507%</a:t>
                       </a:r>
@@ -5235,7 +5235,7 @@
           <p:cNvPr id="5" name="">
             <a:extLst xmlns:a="http://schemas.openxmlformats.org/drawingml/2006/main">
               <a:ext uri="{FF2B5EF4-FFF2-40B4-BE49-F238E27FC236}">
-                <a16:creationId xmlns:a16="http://schemas.microsoft.com/office/drawing/2014/main" id="{2C4C907B-069A-4743-8108-FAA9B4FBCA7E}"/>
+                <a16:creationId xmlns:a16="http://schemas.microsoft.com/office/drawing/2014/main" id="{382B5CCE-A864-4663-A37E-CAF27E962782}"/>
               </a:ext>
             </a:extLst>
           </p:cNvPr>
@@ -5266,21 +5266,21 @@
             <a:pPr>
               <a:defRPr sz="1725" b="0">
                 <a:solidFill>
-                  <a:srgbClr val="192D3D"/>
-                </a:solidFill>
-                <a:latin typeface="DejaVu Sans"/>
-                <a:ea typeface="DejaVu Sans"/>
-                <a:cs typeface="DejaVu Sans"/>
+                  <a:srgbClr val="262321"/>
+                </a:solidFill>
+                <a:latin typeface="Liberation Sans"/>
+                <a:ea typeface="Liberation Sans"/>
+                <a:cs typeface="Liberation Sans"/>
               </a:defRPr>
             </a:pPr>
             <a:r>
               <a:rPr sz="1725" b="0">
                 <a:solidFill>
-                  <a:srgbClr val="192D3D"/>
-                </a:solidFill>
-                <a:latin typeface="DejaVu Sans"/>
-                <a:ea typeface="DejaVu Sans"/>
-                <a:cs typeface="DejaVu Sans"/>
+                  <a:srgbClr val="262321"/>
+                </a:solidFill>
+                <a:latin typeface="Liberation Sans"/>
+                <a:ea typeface="Liberation Sans"/>
+                <a:cs typeface="Liberation Sans"/>
               </a:rPr>
               <a:t>Joint recovery: localization ≤ 0.08 AND relative Q error ≤ 20%</a:t>
             </a:r>
@@ -5292,7 +5292,7 @@
           <p:cNvPr id="6" name="">
             <a:extLst xmlns:a="http://schemas.openxmlformats.org/drawingml/2006/main">
               <a:ext uri="{FF2B5EF4-FFF2-40B4-BE49-F238E27FC236}">
-                <a16:creationId xmlns:a16="http://schemas.microsoft.com/office/drawing/2014/main" id="{DC420B0C-53CC-476B-A0D8-28A4660D9318}"/>
+                <a16:creationId xmlns:a16="http://schemas.microsoft.com/office/drawing/2014/main" id="{4B5BCD23-2DC6-4486-8C87-368F44862748}"/>
               </a:ext>
             </a:extLst>
           </p:cNvPr>
@@ -5323,21 +5323,21 @@
             <a:pPr>
               <a:defRPr sz="1275" b="0">
                 <a:solidFill>
-                  <a:srgbClr val="61717B"/>
-                </a:solidFill>
-                <a:latin typeface="DejaVu Sans"/>
-                <a:ea typeface="DejaVu Sans"/>
-                <a:cs typeface="DejaVu Sans"/>
+                  <a:srgbClr val="716A65"/>
+                </a:solidFill>
+                <a:latin typeface="Liberation Sans"/>
+                <a:ea typeface="Liberation Sans"/>
+                <a:cs typeface="Liberation Sans"/>
               </a:defRPr>
             </a:pPr>
             <a:r>
               <a:rPr sz="1275" b="0">
                 <a:solidFill>
-                  <a:srgbClr val="61717B"/>
-                </a:solidFill>
-                <a:latin typeface="DejaVu Sans"/>
-                <a:ea typeface="DejaVu Sans"/>
-                <a:cs typeface="DejaVu Sans"/>
+                  <a:srgbClr val="716A65"/>
+                </a:solidFill>
+                <a:latin typeface="Liberation Sans"/>
+                <a:ea typeface="Liberation Sans"/>
+                <a:cs typeface="Liberation Sans"/>
               </a:rPr>
               <a:t>9</a:t>
             </a:r>
@@ -5347,7 +5347,7 @@
     </p:spTree>
     <p:extLst>
       <p:ext uri="{BB962C8B-B14F-4D97-AF65-F5344CB8AC3E}">
-        <p14:creationId xmlns:p14="http://schemas.microsoft.com/office/powerpoint/2010/main" val="1216741050"/>
+        <p14:creationId xmlns:p14="http://schemas.microsoft.com/office/powerpoint/2010/main" val="1973240901"/>
       </p:ext>
     </p:extLst>
   </p:cSld>

</xml_diff>